<commit_message>
docs(deck): final voice results (74 %, self-correction 0.765), latency and test count
The submitted deck's results slide, latency line and test counts now
match the final full voice run and the README; values replaced in place,
layout unchanged (rendered and checked). The generated deck and its
builder carry the same numbers.

Claude-Session: https://claude.ai/code/session_01NTYbYeHNX8eZTQQA8UwCCg
</commit_message>
<xml_diff>
--- a/VITVellore_AICA_Submission.pptx
+++ b/VITVellore_AICA_Submission.pptx
@@ -18828,7 +18828,7 @@
                 </a:solidFill>
                 <a:latin typeface="Calibri"/>
               </a:rPr>
-              <a:t>0.412</a:t>
+              <a:t>0.765</a:t>
             </a:r>
           </a:p>
           <a:p>
@@ -19030,7 +19030,7 @@
                           </a:solidFill>
                           <a:latin typeface="Calibri"/>
                         </a:rPr>
-                        <a:t>0.412</a:t>
+                        <a:t>0.765</a:t>
                       </a:r>
                     </a:p>
                   </a:txBody>
@@ -19588,7 +19588,7 @@
                           </a:solidFill>
                           <a:latin typeface="Calibri"/>
                         </a:rPr>
-                        <a:t>42.0% (41% exact)</a:t>
+                        <a:t>74.0% (68% exact)</a:t>
                       </a:r>
                     </a:p>
                   </a:txBody>
@@ -19611,7 +19611,7 @@
                           </a:solidFill>
                           <a:latin typeface="Calibri"/>
                         </a:rPr>
-                        <a:t>0.844</a:t>
+                        <a:t>0.959</a:t>
                       </a:r>
                     </a:p>
                   </a:txBody>
@@ -19634,7 +19634,7 @@
                           </a:solidFill>
                           <a:latin typeface="Calibri"/>
                         </a:rPr>
-                        <a:t>0.611</a:t>
+                        <a:t>0.780</a:t>
                       </a:r>
                     </a:p>
                   </a:txBody>
@@ -19657,7 +19657,7 @@
                           </a:solidFill>
                           <a:latin typeface="Calibri"/>
                         </a:rPr>
-                        <a:t>0.597</a:t>
+                        <a:t>0.720</a:t>
                       </a:r>
                     </a:p>
                   </a:txBody>
@@ -19875,7 +19875,7 @@
                 </a:solidFill>
                 <a:latin typeface="Calibri"/>
               </a:rPr>
-              <a:t>7.8 s mean time to first word (6.7 s median) vs 8.78 s for the cascaded pipeline; part of it is deliberate (a turn closes after 1.5 s of silence, and writes wait a short settle window so late corrections land).</a:t>
+              <a:t>8.5 s mean time to first word (final 100-recording run) vs 8.78 s for the cascaded pipeline; part of it is deliberate (a turn closes after 1.5 s of silence, and writes wait a short settle window so late corrections land).</a:t>
             </a:r>
           </a:p>
           <a:p>
@@ -19904,7 +19904,7 @@
                 </a:solidFill>
                 <a:latin typeface="Calibri"/>
               </a:rPr>
-              <a:t>499 deterministic tests pass with the trace checker run over every decision log; replays are byte-identical; the adversarial explorer covers 19 race scenarios.</a:t>
+              <a:t>622 deterministic tests pass with the trace checker run over every decision log; replays are byte-identical; the adversarial explorer covers 19 race scenarios.</a:t>
             </a:r>
           </a:p>
         </p:txBody>
@@ -19967,7 +19967,7 @@
                 </a:solidFill>
                 <a:latin typeface="Calibri"/>
               </a:rPr>
-              <a:t>Voice trails text replay (42.0% vs 77.0%), largely from misheard proper nouns; Housing (35%) is the hardest domain for every published system too.</a:t>
+              <a:t>Voice nearly matches text replay (74.0% vs 77.0%; 3 Oct runs: 73/65/74%); Housing (35%) is the hardest domain for every published system too.</a:t>
             </a:r>
           </a:p>
           <a:p>
@@ -20691,7 +20691,7 @@
                   <a:schemeClr val="tx1"/>
                 </a:solidFill>
               </a:rPr>
-              <a:t>  • Verification &amp; Testing: pytest (499 deterministic tests) + TraceChecker (commit gate &amp; floor rule audits)</a:t>
+              <a:t>  • Verification &amp; Testing: pytest (622 deterministic tests) + TraceChecker (commit gate &amp; floor rule audits)</a:t>
             </a:r>
           </a:p>
           <a:p>

</xml_diff>

<commit_message>
docs: 4 Oct replay, label guidance and handoff; test count 635
README: the filter-update misses are fixed after the voice run (text
replay), conditional scenarios noted, a results bullet for the 4 Oct full
text replay (76/100; the conditional fix is a deliberate move away from
labels that expect both branches). benchmarks: the two 4 Oct replays
labelled and the record regenerated. currentStatus: the organizer guidance
and decision, the 4 Oct fixes, a new handoff block. Test count 635 in the
README, CLAUDE.md and both decks.

Claude-Session: https://claude.ai/code/session_01NTYbYeHNX8eZTQQA8UwCCg
</commit_message>
<xml_diff>
--- a/VITVellore_AICA_Submission.pptx
+++ b/VITVellore_AICA_Submission.pptx
@@ -19904,7 +19904,7 @@
                 </a:solidFill>
                 <a:latin typeface="Calibri"/>
               </a:rPr>
-              <a:t>622 deterministic tests pass with the trace checker run over every decision log; replays are byte-identical; the adversarial explorer covers 19 race scenarios.</a:t>
+              <a:t>635 deterministic tests pass with the trace checker run over every decision log; replays are byte-identical; the adversarial explorer covers 19 race scenarios.</a:t>
             </a:r>
           </a:p>
         </p:txBody>
@@ -20691,7 +20691,7 @@
                   <a:schemeClr val="tx1"/>
                 </a:solidFill>
               </a:rPr>
-              <a:t>  • Verification &amp; Testing: pytest (622 deterministic tests) + TraceChecker (commit gate &amp; floor rule audits)</a:t>
+              <a:t>  • Verification &amp; Testing: pytest (635 deterministic tests) + TraceChecker (commit gate &amp; floor rule audits)</a:t>
             </a:r>
           </a:p>
           <a:p>

</xml_diff>

<commit_message>
deck: the current deck (74 %, self-correction 0.765, 645 tests) under the submission name; remove the duplicate copy
Claude-Session: https://claude.ai/code/session_01NTYbYeHNX8eZTQQA8UwCCg
</commit_message>
<xml_diff>
--- a/VITVellore_AICA_Submission.pptx
+++ b/VITVellore_AICA_Submission.pptx
@@ -5,17 +5,17 @@
     <p:sldMasterId id="2147483648" r:id="rId1"/>
   </p:sldMasterIdLst>
   <p:notesMasterIdLst>
-    <p:notesMasterId r:id="rId13"/>
+    <p:notesMasterId r:id="rId10"/>
   </p:notesMasterIdLst>
   <p:sldIdLst>
     <p:sldId id="256" r:id="rId2"/>
     <p:sldId id="257" r:id="rId3"/>
-    <p:sldId id="258" r:id="rId5"/>
-    <p:sldId id="259" r:id="rId6"/>
-    <p:sldId id="265" r:id="rId9"/>
-    <p:sldId id="262" r:id="rId10"/>
+    <p:sldId id="258" r:id="rId4"/>
+    <p:sldId id="259" r:id="rId5"/>
+    <p:sldId id="265" r:id="rId6"/>
+    <p:sldId id="262" r:id="rId7"/>
     <p:sldId id="261" r:id="rId8"/>
-    <p:sldId id="263" r:id="rId11"/>
+    <p:sldId id="263" r:id="rId9"/>
   </p:sldIdLst>
   <p:sldSz cx="12192000" cy="6858000"/>
   <p:notesSz cx="6858000" cy="9144000"/>
@@ -1884,128 +1884,6 @@
 </p:notes>
 </file>
 
-<file path=ppt/notesSlides/notesSlide10.xml><?xml version="1.0" encoding="utf-8"?>
-<p:notes xmlns:a="http://schemas.openxmlformats.org/drawingml/2006/main" xmlns:r="http://schemas.openxmlformats.org/officeDocument/2006/relationships" xmlns:p="http://schemas.openxmlformats.org/presentationml/2006/main" showMasterSp="0" showMasterPhAnim="0">
-  <p:cSld>
-    <p:spTree>
-      <p:nvGrpSpPr>
-        <p:cNvPr id="1" name="Shape 143"/>
-        <p:cNvGrpSpPr/>
-        <p:nvPr/>
-      </p:nvGrpSpPr>
-      <p:grpSpPr>
-        <a:xfrm>
-          <a:off x="0" y="0"/>
-          <a:ext cx="0" cy="0"/>
-          <a:chOff x="0" y="0"/>
-          <a:chExt cx="0" cy="0"/>
-        </a:xfrm>
-      </p:grpSpPr>
-      <p:sp>
-        <p:nvSpPr>
-          <p:cNvPr id="144" name="Google Shape;144;p9:notes"/>
-          <p:cNvSpPr txBox="1">
-            <a:spLocks noGrp="1"/>
-          </p:cNvSpPr>
-          <p:nvPr>
-            <p:ph type="body" idx="1"/>
-          </p:nvPr>
-        </p:nvSpPr>
-        <p:spPr>
-          <a:xfrm>
-            <a:off x="685800" y="4400550"/>
-            <a:ext cx="5486400" cy="3600450"/>
-          </a:xfrm>
-          <a:prstGeom prst="rect">
-            <a:avLst/>
-          </a:prstGeom>
-          <a:noFill/>
-          <a:ln>
-            <a:noFill/>
-          </a:ln>
-        </p:spPr>
-        <p:txBody>
-          <a:bodyPr spcFirstLastPara="1" wrap="square" lIns="91425" tIns="45700" rIns="91425" bIns="45700" anchor="t" anchorCtr="0">
-            <a:noAutofit/>
-          </a:bodyPr>
-          <a:lstStyle/>
-          <a:p>
-            <a:pPr marL="0" lvl="0" indent="0" algn="l" rtl="0">
-              <a:lnSpc>
-                <a:spcPct val="100000"/>
-              </a:lnSpc>
-              <a:spcBef>
-                <a:spcPts val="0"/>
-              </a:spcBef>
-              <a:spcAft>
-                <a:spcPts val="0"/>
-              </a:spcAft>
-              <a:buSzPts val="1400"/>
-              <a:buNone/>
-            </a:pPr>
-            <a:endParaRPr/>
-          </a:p>
-        </p:txBody>
-      </p:sp>
-      <p:sp>
-        <p:nvSpPr>
-          <p:cNvPr id="145" name="Google Shape;145;p9:notes"/>
-          <p:cNvSpPr>
-            <a:spLocks noGrp="1" noRot="1" noChangeAspect="1"/>
-          </p:cNvSpPr>
-          <p:nvPr>
-            <p:ph type="sldImg" idx="2"/>
-          </p:nvPr>
-        </p:nvSpPr>
-        <p:spPr>
-          <a:xfrm>
-            <a:off x="685800" y="1143000"/>
-            <a:ext cx="5486400" cy="3086100"/>
-          </a:xfrm>
-          <a:custGeom>
-            <a:avLst/>
-            <a:gdLst/>
-            <a:ahLst/>
-            <a:cxnLst/>
-            <a:rect l="l" t="t" r="r" b="b"/>
-            <a:pathLst>
-              <a:path w="120000" h="120000" extrusionOk="0">
-                <a:moveTo>
-                  <a:pt x="0" y="0"/>
-                </a:moveTo>
-                <a:lnTo>
-                  <a:pt x="120000" y="0"/>
-                </a:lnTo>
-                <a:lnTo>
-                  <a:pt x="120000" y="120000"/>
-                </a:lnTo>
-                <a:lnTo>
-                  <a:pt x="0" y="120000"/>
-                </a:lnTo>
-                <a:close/>
-              </a:path>
-            </a:pathLst>
-          </a:custGeom>
-          <a:noFill/>
-          <a:ln w="12700" cap="flat" cmpd="sng">
-            <a:solidFill>
-              <a:srgbClr val="000000"/>
-            </a:solidFill>
-            <a:prstDash val="solid"/>
-            <a:round/>
-            <a:headEnd type="none" w="sm" len="sm"/>
-            <a:tailEnd type="none" w="sm" len="sm"/>
-          </a:ln>
-        </p:spPr>
-      </p:sp>
-    </p:spTree>
-  </p:cSld>
-  <p:clrMapOvr>
-    <a:masterClrMapping/>
-  </p:clrMapOvr>
-</p:notes>
-</file>
-
 <file path=ppt/notesSlides/notesSlide2.xml><?xml version="1.0" encoding="utf-8"?>
 <p:notes xmlns:a="http://schemas.openxmlformats.org/drawingml/2006/main" xmlns:r="http://schemas.openxmlformats.org/officeDocument/2006/relationships" xmlns:p="http://schemas.openxmlformats.org/presentationml/2006/main" showMasterSp="0" showMasterPhAnim="0">
   <p:cSld>
@@ -2128,7 +2006,7 @@
 </p:notes>
 </file>
 
-<file path=ppt/notesSlides/notesSlide4.xml><?xml version="1.0" encoding="utf-8"?>
+<file path=ppt/notesSlides/notesSlide3.xml><?xml version="1.0" encoding="utf-8"?>
 <p:notes xmlns:a="http://schemas.openxmlformats.org/drawingml/2006/main" xmlns:r="http://schemas.openxmlformats.org/officeDocument/2006/relationships" xmlns:p="http://schemas.openxmlformats.org/presentationml/2006/main" showMasterSp="0" showMasterPhAnim="0">
   <p:cSld>
     <p:spTree>
@@ -2250,7 +2128,7 @@
 </p:notes>
 </file>
 
-<file path=ppt/notesSlides/notesSlide5.xml><?xml version="1.0" encoding="utf-8"?>
+<file path=ppt/notesSlides/notesSlide4.xml><?xml version="1.0" encoding="utf-8"?>
 <p:notes xmlns:a="http://schemas.openxmlformats.org/drawingml/2006/main" xmlns:r="http://schemas.openxmlformats.org/officeDocument/2006/relationships" xmlns:p="http://schemas.openxmlformats.org/presentationml/2006/main" showMasterSp="0" showMasterPhAnim="0">
   <p:cSld>
     <p:spTree>
@@ -2354,129 +2232,7 @@
 </p:notes>
 </file>
 
-<file path=ppt/notesSlides/notesSlide7.xml><?xml version="1.0" encoding="utf-8"?>
-<p:notes xmlns:a="http://schemas.openxmlformats.org/drawingml/2006/main" xmlns:r="http://schemas.openxmlformats.org/officeDocument/2006/relationships" xmlns:p="http://schemas.openxmlformats.org/presentationml/2006/main" showMasterSp="0" showMasterPhAnim="0">
-  <p:cSld>
-    <p:spTree>
-      <p:nvGrpSpPr>
-        <p:cNvPr id="1" name="Shape 131"/>
-        <p:cNvGrpSpPr/>
-        <p:nvPr/>
-      </p:nvGrpSpPr>
-      <p:grpSpPr>
-        <a:xfrm>
-          <a:off x="0" y="0"/>
-          <a:ext cx="0" cy="0"/>
-          <a:chOff x="0" y="0"/>
-          <a:chExt cx="0" cy="0"/>
-        </a:xfrm>
-      </p:grpSpPr>
-      <p:sp>
-        <p:nvSpPr>
-          <p:cNvPr id="132" name="Google Shape;132;p6:notes"/>
-          <p:cNvSpPr txBox="1">
-            <a:spLocks noGrp="1"/>
-          </p:cNvSpPr>
-          <p:nvPr>
-            <p:ph type="body" idx="1"/>
-          </p:nvPr>
-        </p:nvSpPr>
-        <p:spPr>
-          <a:xfrm>
-            <a:off x="685800" y="4400550"/>
-            <a:ext cx="5486400" cy="3600450"/>
-          </a:xfrm>
-          <a:prstGeom prst="rect">
-            <a:avLst/>
-          </a:prstGeom>
-          <a:noFill/>
-          <a:ln>
-            <a:noFill/>
-          </a:ln>
-        </p:spPr>
-        <p:txBody>
-          <a:bodyPr spcFirstLastPara="1" wrap="square" lIns="91425" tIns="45700" rIns="91425" bIns="45700" anchor="t" anchorCtr="0">
-            <a:noAutofit/>
-          </a:bodyPr>
-          <a:lstStyle/>
-          <a:p>
-            <a:pPr marL="0" lvl="0" indent="0" algn="l" rtl="0">
-              <a:lnSpc>
-                <a:spcPct val="100000"/>
-              </a:lnSpc>
-              <a:spcBef>
-                <a:spcPts val="0"/>
-              </a:spcBef>
-              <a:spcAft>
-                <a:spcPts val="0"/>
-              </a:spcAft>
-              <a:buSzPts val="1400"/>
-              <a:buNone/>
-            </a:pPr>
-            <a:endParaRPr/>
-          </a:p>
-        </p:txBody>
-      </p:sp>
-      <p:sp>
-        <p:nvSpPr>
-          <p:cNvPr id="133" name="Google Shape;133;p6:notes"/>
-          <p:cNvSpPr>
-            <a:spLocks noGrp="1" noRot="1" noChangeAspect="1"/>
-          </p:cNvSpPr>
-          <p:nvPr>
-            <p:ph type="sldImg" idx="2"/>
-          </p:nvPr>
-        </p:nvSpPr>
-        <p:spPr>
-          <a:xfrm>
-            <a:off x="685800" y="1143000"/>
-            <a:ext cx="5486400" cy="3086100"/>
-          </a:xfrm>
-          <a:custGeom>
-            <a:avLst/>
-            <a:gdLst/>
-            <a:ahLst/>
-            <a:cxnLst/>
-            <a:rect l="l" t="t" r="r" b="b"/>
-            <a:pathLst>
-              <a:path w="120000" h="120000" extrusionOk="0">
-                <a:moveTo>
-                  <a:pt x="0" y="0"/>
-                </a:moveTo>
-                <a:lnTo>
-                  <a:pt x="120000" y="0"/>
-                </a:lnTo>
-                <a:lnTo>
-                  <a:pt x="120000" y="120000"/>
-                </a:lnTo>
-                <a:lnTo>
-                  <a:pt x="0" y="120000"/>
-                </a:lnTo>
-                <a:close/>
-              </a:path>
-            </a:pathLst>
-          </a:custGeom>
-          <a:noFill/>
-          <a:ln w="12700" cap="flat" cmpd="sng">
-            <a:solidFill>
-              <a:srgbClr val="000000"/>
-            </a:solidFill>
-            <a:prstDash val="solid"/>
-            <a:round/>
-            <a:headEnd type="none" w="sm" len="sm"/>
-            <a:tailEnd type="none" w="sm" len="sm"/>
-          </a:ln>
-        </p:spPr>
-      </p:sp>
-    </p:spTree>
-  </p:cSld>
-  <p:clrMapOvr>
-    <a:masterClrMapping/>
-  </p:clrMapOvr>
-</p:notes>
-</file>
-
-<file path=ppt/notesSlides/notesSlide8.xml><?xml version="1.0" encoding="utf-8"?>
+<file path=ppt/notesSlides/notesSlide5.xml><?xml version="1.0" encoding="utf-8"?>
 <p:notes xmlns:a="http://schemas.openxmlformats.org/drawingml/2006/main" xmlns:r="http://schemas.openxmlformats.org/officeDocument/2006/relationships" xmlns:p="http://schemas.openxmlformats.org/presentationml/2006/main" showMasterSp="0" showMasterPhAnim="0">
   <p:cSld>
     <p:spTree>
@@ -2621,7 +2377,7 @@
 </p:notes>
 </file>
 
-<file path=ppt/notesSlides/notesSlide9.xml><?xml version="1.0" encoding="utf-8"?>
+<file path=ppt/notesSlides/notesSlide6.xml><?xml version="1.0" encoding="utf-8"?>
 <p:notes xmlns:a="http://schemas.openxmlformats.org/drawingml/2006/main" xmlns:r="http://schemas.openxmlformats.org/officeDocument/2006/relationships" xmlns:p="http://schemas.openxmlformats.org/presentationml/2006/main" showMasterSp="0" showMasterPhAnim="0">
   <p:cSld>
     <p:spTree>
@@ -2676,6 +2432,250 @@
       <p:sp>
         <p:nvSpPr>
           <p:cNvPr id="139" name="Google Shape;139;p8:notes"/>
+          <p:cNvSpPr>
+            <a:spLocks noGrp="1" noRot="1" noChangeAspect="1"/>
+          </p:cNvSpPr>
+          <p:nvPr>
+            <p:ph type="sldImg" idx="2"/>
+          </p:nvPr>
+        </p:nvSpPr>
+        <p:spPr>
+          <a:xfrm>
+            <a:off x="685800" y="1143000"/>
+            <a:ext cx="5486400" cy="3086100"/>
+          </a:xfrm>
+          <a:custGeom>
+            <a:avLst/>
+            <a:gdLst/>
+            <a:ahLst/>
+            <a:cxnLst/>
+            <a:rect l="l" t="t" r="r" b="b"/>
+            <a:pathLst>
+              <a:path w="120000" h="120000" extrusionOk="0">
+                <a:moveTo>
+                  <a:pt x="0" y="0"/>
+                </a:moveTo>
+                <a:lnTo>
+                  <a:pt x="120000" y="0"/>
+                </a:lnTo>
+                <a:lnTo>
+                  <a:pt x="120000" y="120000"/>
+                </a:lnTo>
+                <a:lnTo>
+                  <a:pt x="0" y="120000"/>
+                </a:lnTo>
+                <a:close/>
+              </a:path>
+            </a:pathLst>
+          </a:custGeom>
+          <a:noFill/>
+          <a:ln w="12700" cap="flat" cmpd="sng">
+            <a:solidFill>
+              <a:srgbClr val="000000"/>
+            </a:solidFill>
+            <a:prstDash val="solid"/>
+            <a:round/>
+            <a:headEnd type="none" w="sm" len="sm"/>
+            <a:tailEnd type="none" w="sm" len="sm"/>
+          </a:ln>
+        </p:spPr>
+      </p:sp>
+    </p:spTree>
+  </p:cSld>
+  <p:clrMapOvr>
+    <a:masterClrMapping/>
+  </p:clrMapOvr>
+</p:notes>
+</file>
+
+<file path=ppt/notesSlides/notesSlide7.xml><?xml version="1.0" encoding="utf-8"?>
+<p:notes xmlns:a="http://schemas.openxmlformats.org/drawingml/2006/main" xmlns:r="http://schemas.openxmlformats.org/officeDocument/2006/relationships" xmlns:p="http://schemas.openxmlformats.org/presentationml/2006/main" showMasterSp="0" showMasterPhAnim="0">
+  <p:cSld>
+    <p:spTree>
+      <p:nvGrpSpPr>
+        <p:cNvPr id="1" name="Shape 131"/>
+        <p:cNvGrpSpPr/>
+        <p:nvPr/>
+      </p:nvGrpSpPr>
+      <p:grpSpPr>
+        <a:xfrm>
+          <a:off x="0" y="0"/>
+          <a:ext cx="0" cy="0"/>
+          <a:chOff x="0" y="0"/>
+          <a:chExt cx="0" cy="0"/>
+        </a:xfrm>
+      </p:grpSpPr>
+      <p:sp>
+        <p:nvSpPr>
+          <p:cNvPr id="132" name="Google Shape;132;p6:notes"/>
+          <p:cNvSpPr txBox="1">
+            <a:spLocks noGrp="1"/>
+          </p:cNvSpPr>
+          <p:nvPr>
+            <p:ph type="body" idx="1"/>
+          </p:nvPr>
+        </p:nvSpPr>
+        <p:spPr>
+          <a:xfrm>
+            <a:off x="685800" y="4400550"/>
+            <a:ext cx="5486400" cy="3600450"/>
+          </a:xfrm>
+          <a:prstGeom prst="rect">
+            <a:avLst/>
+          </a:prstGeom>
+          <a:noFill/>
+          <a:ln>
+            <a:noFill/>
+          </a:ln>
+        </p:spPr>
+        <p:txBody>
+          <a:bodyPr spcFirstLastPara="1" wrap="square" lIns="91425" tIns="45700" rIns="91425" bIns="45700" anchor="t" anchorCtr="0">
+            <a:noAutofit/>
+          </a:bodyPr>
+          <a:lstStyle/>
+          <a:p>
+            <a:pPr marL="0" lvl="0" indent="0" algn="l" rtl="0">
+              <a:lnSpc>
+                <a:spcPct val="100000"/>
+              </a:lnSpc>
+              <a:spcBef>
+                <a:spcPts val="0"/>
+              </a:spcBef>
+              <a:spcAft>
+                <a:spcPts val="0"/>
+              </a:spcAft>
+              <a:buSzPts val="1400"/>
+              <a:buNone/>
+            </a:pPr>
+            <a:endParaRPr/>
+          </a:p>
+        </p:txBody>
+      </p:sp>
+      <p:sp>
+        <p:nvSpPr>
+          <p:cNvPr id="133" name="Google Shape;133;p6:notes"/>
+          <p:cNvSpPr>
+            <a:spLocks noGrp="1" noRot="1" noChangeAspect="1"/>
+          </p:cNvSpPr>
+          <p:nvPr>
+            <p:ph type="sldImg" idx="2"/>
+          </p:nvPr>
+        </p:nvSpPr>
+        <p:spPr>
+          <a:xfrm>
+            <a:off x="685800" y="1143000"/>
+            <a:ext cx="5486400" cy="3086100"/>
+          </a:xfrm>
+          <a:custGeom>
+            <a:avLst/>
+            <a:gdLst/>
+            <a:ahLst/>
+            <a:cxnLst/>
+            <a:rect l="l" t="t" r="r" b="b"/>
+            <a:pathLst>
+              <a:path w="120000" h="120000" extrusionOk="0">
+                <a:moveTo>
+                  <a:pt x="0" y="0"/>
+                </a:moveTo>
+                <a:lnTo>
+                  <a:pt x="120000" y="0"/>
+                </a:lnTo>
+                <a:lnTo>
+                  <a:pt x="120000" y="120000"/>
+                </a:lnTo>
+                <a:lnTo>
+                  <a:pt x="0" y="120000"/>
+                </a:lnTo>
+                <a:close/>
+              </a:path>
+            </a:pathLst>
+          </a:custGeom>
+          <a:noFill/>
+          <a:ln w="12700" cap="flat" cmpd="sng">
+            <a:solidFill>
+              <a:srgbClr val="000000"/>
+            </a:solidFill>
+            <a:prstDash val="solid"/>
+            <a:round/>
+            <a:headEnd type="none" w="sm" len="sm"/>
+            <a:tailEnd type="none" w="sm" len="sm"/>
+          </a:ln>
+        </p:spPr>
+      </p:sp>
+    </p:spTree>
+  </p:cSld>
+  <p:clrMapOvr>
+    <a:masterClrMapping/>
+  </p:clrMapOvr>
+</p:notes>
+</file>
+
+<file path=ppt/notesSlides/notesSlide8.xml><?xml version="1.0" encoding="utf-8"?>
+<p:notes xmlns:a="http://schemas.openxmlformats.org/drawingml/2006/main" xmlns:r="http://schemas.openxmlformats.org/officeDocument/2006/relationships" xmlns:p="http://schemas.openxmlformats.org/presentationml/2006/main" showMasterSp="0" showMasterPhAnim="0">
+  <p:cSld>
+    <p:spTree>
+      <p:nvGrpSpPr>
+        <p:cNvPr id="1" name="Shape 143"/>
+        <p:cNvGrpSpPr/>
+        <p:nvPr/>
+      </p:nvGrpSpPr>
+      <p:grpSpPr>
+        <a:xfrm>
+          <a:off x="0" y="0"/>
+          <a:ext cx="0" cy="0"/>
+          <a:chOff x="0" y="0"/>
+          <a:chExt cx="0" cy="0"/>
+        </a:xfrm>
+      </p:grpSpPr>
+      <p:sp>
+        <p:nvSpPr>
+          <p:cNvPr id="144" name="Google Shape;144;p9:notes"/>
+          <p:cNvSpPr txBox="1">
+            <a:spLocks noGrp="1"/>
+          </p:cNvSpPr>
+          <p:nvPr>
+            <p:ph type="body" idx="1"/>
+          </p:nvPr>
+        </p:nvSpPr>
+        <p:spPr>
+          <a:xfrm>
+            <a:off x="685800" y="4400550"/>
+            <a:ext cx="5486400" cy="3600450"/>
+          </a:xfrm>
+          <a:prstGeom prst="rect">
+            <a:avLst/>
+          </a:prstGeom>
+          <a:noFill/>
+          <a:ln>
+            <a:noFill/>
+          </a:ln>
+        </p:spPr>
+        <p:txBody>
+          <a:bodyPr spcFirstLastPara="1" wrap="square" lIns="91425" tIns="45700" rIns="91425" bIns="45700" anchor="t" anchorCtr="0">
+            <a:noAutofit/>
+          </a:bodyPr>
+          <a:lstStyle/>
+          <a:p>
+            <a:pPr marL="0" lvl="0" indent="0" algn="l" rtl="0">
+              <a:lnSpc>
+                <a:spcPct val="100000"/>
+              </a:lnSpc>
+              <a:spcBef>
+                <a:spcPts val="0"/>
+              </a:spcBef>
+              <a:spcAft>
+                <a:spcPts val="0"/>
+              </a:spcAft>
+              <a:buSzPts val="1400"/>
+              <a:buNone/>
+            </a:pPr>
+            <a:endParaRPr/>
+          </a:p>
+        </p:txBody>
+      </p:sp>
+      <p:sp>
+        <p:nvSpPr>
+          <p:cNvPr id="145" name="Google Shape;145;p9:notes"/>
           <p:cNvSpPr>
             <a:spLocks noGrp="1" noRot="1" noChangeAspect="1"/>
           </p:cNvSpPr>
@@ -16240,40 +16240,6 @@
                 <a:cs typeface="Arial"/>
                 <a:sym typeface="Arial"/>
               </a:rPr>
-              <a:t>Tagline - </a:t>
-            </a:r>
-            <a:r>
-              <a:rPr lang="en-US" sz="1300" b="1" dirty="0">
-                <a:solidFill>
-                  <a:srgbClr val="0F172A"/>
-                </a:solidFill>
-              </a:rPr>
-              <a:t>The voice agent you can interrupt, correct and trust: models propose, a deterministic kernel decides.</a:t>
-            </a:r>
-          </a:p>
-          <a:p>
-            <a:pPr marL="0" marR="0" lvl="0" indent="0" algn="l" rtl="0">
-              <a:lnSpc>
-                <a:spcPct val="100000"/>
-              </a:lnSpc>
-              <a:spcBef>
-                <a:spcPts val="300"/>
-              </a:spcBef>
-              <a:spcAft>
-                <a:spcPts val="0"/>
-              </a:spcAft>
-              <a:buNone/>
-            </a:pPr>
-            <a:r>
-              <a:rPr lang="en-US" sz="1300" b="1" i="0" strike="noStrike" cap="none" dirty="0">
-                <a:solidFill>
-                  <a:srgbClr val="0F172A"/>
-                </a:solidFill>
-                <a:latin typeface="Arial"/>
-                <a:ea typeface="Arial"/>
-                <a:cs typeface="Arial"/>
-                <a:sym typeface="Arial"/>
-              </a:rPr>
               <a:t>Team Name - </a:t>
             </a:r>
             <a:r>
@@ -16366,19 +16332,19 @@
               </a:spcBef>
             </a:pPr>
             <a:r>
-              <a:rPr lang="en-US" sz="1300" b="1" i="0" strike="noStrike" cap="none" dirty="0">
-                <a:solidFill>
-                  <a:srgbClr val="0F172A"/>
+              <a:rPr lang="en-US" sz="1300" b="0" i="0" strike="noStrike" cap="none" dirty="0">
+                <a:solidFill>
+                  <a:schemeClr val="dk1"/>
                 </a:solidFill>
                 <a:latin typeface="Arial"/>
                 <a:ea typeface="Arial"/>
                 <a:cs typeface="Arial"/>
                 <a:sym typeface="Arial"/>
               </a:rPr>
-              <a:t>Member Name &amp; Email 1 - </a:t>
+              <a:t>Adithya Santhosh P </a:t>
             </a:r>
             <a:r>
-              <a:rPr lang="en-US" sz="1300" b="0" i="0" strike="noStrike" cap="none" dirty="0">
+              <a:rPr lang="en-US" sz="1300" b="0" i="1" strike="noStrike" cap="none" dirty="0">
                 <a:solidFill>
                   <a:schemeClr val="dk1"/>
                 </a:solidFill>
@@ -16387,10 +16353,10 @@
                 <a:cs typeface="Arial"/>
                 <a:sym typeface="Arial"/>
               </a:rPr>
-              <a:t>Adithya Santhosh P (</a:t>
+              <a:t>(</a:t>
             </a:r>
             <a:r>
-              <a:rPr lang="en-US" sz="1300" dirty="0">
+              <a:rPr lang="en-US" sz="1300" i="1" dirty="0">
                 <a:solidFill>
                   <a:schemeClr val="dk1"/>
                 </a:solidFill>
@@ -16398,7 +16364,7 @@
               <a:t>adithyasanthosh.p2024@vitstudent.ac.in</a:t>
             </a:r>
             <a:r>
-              <a:rPr lang="en-US" sz="1300" b="0" i="0" strike="noStrike" cap="none" dirty="0">
+              <a:rPr lang="en-US" sz="1300" b="0" i="1" strike="noStrike" cap="none" dirty="0">
                 <a:solidFill>
                   <a:schemeClr val="dk1"/>
                 </a:solidFill>
@@ -16409,7 +16375,7 @@
               </a:rPr>
               <a:t>)</a:t>
             </a:r>
-            <a:endParaRPr dirty="0"/>
+            <a:endParaRPr i="1" dirty="0"/>
           </a:p>
           <a:p>
             <a:pPr marL="0" marR="0" lvl="0" indent="0" algn="l" rtl="0">
@@ -16425,7 +16391,7 @@
               <a:buNone/>
             </a:pPr>
             <a:r>
-              <a:rPr lang="en-US" sz="1300" b="1" i="0" strike="noStrike" cap="none" dirty="0">
+              <a:rPr lang="en-US" sz="1300" b="0" i="0" strike="noStrike" cap="none" dirty="0">
                 <a:solidFill>
                   <a:srgbClr val="0F172A"/>
                 </a:solidFill>
@@ -16434,10 +16400,10 @@
                 <a:cs typeface="Arial"/>
                 <a:sym typeface="Arial"/>
               </a:rPr>
-              <a:t>Member Name &amp; Email 2 - </a:t>
+              <a:t>Eldo John </a:t>
             </a:r>
             <a:r>
-              <a:rPr lang="en-US" sz="1300" b="0" i="0" strike="noStrike" cap="none" dirty="0">
+              <a:rPr lang="en-US" sz="1300" b="0" strike="noStrike" cap="none" dirty="0">
                 <a:solidFill>
                   <a:srgbClr val="0F172A"/>
                 </a:solidFill>
@@ -16446,9 +16412,21 @@
                 <a:cs typeface="Arial"/>
                 <a:sym typeface="Arial"/>
               </a:rPr>
-              <a:t>Eldo John Giby (eldo.johngiby2024@vitstudent.ac.in)</a:t>
+              <a:t>Giby </a:t>
             </a:r>
-            <a:endParaRPr sz="1300" b="0" i="0" strike="noStrike" cap="none" dirty="0">
+            <a:r>
+              <a:rPr lang="en-US" sz="1300" b="0" i="1" strike="noStrike" cap="none" dirty="0">
+                <a:solidFill>
+                  <a:srgbClr val="0F172A"/>
+                </a:solidFill>
+                <a:latin typeface="Arial"/>
+                <a:ea typeface="Arial"/>
+                <a:cs typeface="Arial"/>
+                <a:sym typeface="Arial"/>
+              </a:rPr>
+              <a:t>(eldo.johngiby2024@vitstudent.ac.in)</a:t>
+            </a:r>
+            <a:endParaRPr sz="1300" b="0" i="1" strike="noStrike" cap="none" dirty="0">
               <a:solidFill>
                 <a:srgbClr val="334155"/>
               </a:solidFill>
@@ -16465,18 +16443,6 @@
               </a:spcBef>
             </a:pPr>
             <a:r>
-              <a:rPr lang="en-US" sz="1300" b="1" i="0" strike="noStrike" cap="none" dirty="0">
-                <a:solidFill>
-                  <a:srgbClr val="0F172A"/>
-                </a:solidFill>
-                <a:latin typeface="Arial"/>
-                <a:ea typeface="Arial"/>
-                <a:cs typeface="Arial"/>
-                <a:sym typeface="Arial"/>
-              </a:rPr>
-              <a:t>Member Name &amp; Email 3 - </a:t>
-            </a:r>
-            <a:r>
               <a:rPr lang="en-US" sz="1300" b="0" i="0" strike="noStrike" cap="none" dirty="0">
                 <a:solidFill>
                   <a:srgbClr val="0F172A"/>
@@ -16518,9 +16484,17 @@
                   <a:srgbClr val="0F172A"/>
                 </a:solidFill>
               </a:rPr>
-              <a:t>r (ramarathinamiyer.vv2024@vitstudent.ac.in)</a:t>
+              <a:t>r </a:t>
             </a:r>
-            <a:endParaRPr sz="1300" b="0" i="0" strike="noStrike" cap="none" dirty="0">
+            <a:r>
+              <a:rPr lang="en-US" sz="1300" i="1" dirty="0">
+                <a:solidFill>
+                  <a:srgbClr val="0F172A"/>
+                </a:solidFill>
+              </a:rPr>
+              <a:t>(ramarathinamiyer.vv2024@vitstudent.ac.in)</a:t>
+            </a:r>
+            <a:endParaRPr sz="1300" b="0" i="1" strike="noStrike" cap="none" dirty="0">
               <a:solidFill>
                 <a:srgbClr val="334155"/>
               </a:solidFill>
@@ -16537,24 +16511,20 @@
               </a:spcBef>
             </a:pPr>
             <a:r>
-              <a:rPr lang="en-US" sz="1300" b="1" i="0" strike="noStrike" cap="none" dirty="0">
+              <a:rPr lang="en-US" sz="1300" dirty="0">
                 <a:solidFill>
                   <a:srgbClr val="0F172A"/>
                 </a:solidFill>
-                <a:latin typeface="Arial"/>
-                <a:ea typeface="Arial"/>
-                <a:cs typeface="Arial"/>
-                <a:sym typeface="Arial"/>
               </a:rPr>
-              <a:t>Member Name &amp; Email 4 -</a:t>
+              <a:t>Aryaman Tripathi </a:t>
             </a:r>
             <a:r>
-              <a:rPr lang="en-US" sz="1300" dirty="0">
+              <a:rPr lang="en-US" sz="1300" i="1" dirty="0">
                 <a:solidFill>
                   <a:srgbClr val="0F172A"/>
                 </a:solidFill>
               </a:rPr>
-              <a:t> Aryaman Tripathi (aryaman.tripathi2024@vitstudent.ac.in)</a:t>
+              <a:t>(aryaman.tripathi2024@vitstudent.ac.in)</a:t>
             </a:r>
           </a:p>
           <a:p>
@@ -16628,19 +16598,15 @@
                 <a:cs typeface="Arial"/>
                 <a:sym typeface="Arial"/>
               </a:rPr>
-              <a:t>Demo video link - </a:t>
+              <a:t>Demo video link – </a:t>
             </a:r>
             <a:r>
-              <a:rPr lang="en-US" sz="1300" b="1" i="0" strike="noStrike" cap="none" dirty="0">
+              <a:rPr lang="en-US" sz="1300" b="1" dirty="0">
                 <a:solidFill>
                   <a:srgbClr val="1E3A8A"/>
                 </a:solidFill>
-                <a:latin typeface="Arial"/>
-                <a:ea typeface="Arial"/>
-                <a:cs typeface="Arial"/>
-                <a:sym typeface="Arial"/>
               </a:rPr>
-              <a:t>[paste demo video URL here]</a:t>
+              <a:t>Check Readme</a:t>
             </a:r>
             <a:endParaRPr dirty="0"/>
           </a:p>
@@ -16711,404 +16677,6 @@
 </p:sld>
 </file>
 
-<file path=ppt/slides/slide10.xml><?xml version="1.0" encoding="utf-8"?>
-<p:sld xmlns:a="http://schemas.openxmlformats.org/drawingml/2006/main" xmlns:r="http://schemas.openxmlformats.org/officeDocument/2006/relationships" xmlns:p="http://schemas.openxmlformats.org/presentationml/2006/main">
-  <p:cSld>
-    <p:spTree>
-      <p:nvGrpSpPr>
-        <p:cNvPr id="1" name="Shape 146"/>
-        <p:cNvGrpSpPr/>
-        <p:nvPr/>
-      </p:nvGrpSpPr>
-      <p:grpSpPr>
-        <a:xfrm>
-          <a:off x="0" y="0"/>
-          <a:ext cx="0" cy="0"/>
-          <a:chOff x="0" y="0"/>
-          <a:chExt cx="0" cy="0"/>
-        </a:xfrm>
-      </p:grpSpPr>
-      <p:sp>
-        <p:nvSpPr>
-          <p:cNvPr id="147" name="Google Shape;147;p9"/>
-          <p:cNvSpPr txBox="1">
-            <a:spLocks noGrp="1"/>
-          </p:cNvSpPr>
-          <p:nvPr>
-            <p:ph type="title"/>
-          </p:nvPr>
-        </p:nvSpPr>
-        <p:spPr>
-          <a:xfrm>
-            <a:off x="457200" y="228600"/>
-            <a:ext cx="11247120" cy="731520"/>
-          </a:xfrm>
-          <a:prstGeom prst="rect">
-            <a:avLst/>
-          </a:prstGeom>
-          <a:noFill/>
-          <a:ln>
-            <a:noFill/>
-          </a:ln>
-        </p:spPr>
-        <p:txBody>
-          <a:bodyPr spcFirstLastPara="1" wrap="square" lIns="91425" tIns="45700" rIns="91425" bIns="45700" anchor="ctr" anchorCtr="0">
-            <a:normAutofit/>
-          </a:bodyPr>
-          <a:lstStyle/>
-          <a:p>
-            <a:pPr lvl="0"/>
-            <a:r>
-              <a:rPr lang="en-US" b="1" dirty="0" sz="3200">
-                <a:solidFill>
-                  <a:srgbClr val="704EA6"/>
-                </a:solidFill>
-              </a:rPr>
-              <a:t>What’s Next</a:t>
-            </a:r>
-            <a:endParaRPr dirty="0"/>
-          </a:p>
-        </p:txBody>
-      </p:sp>
-      <p:sp>
-        <p:nvSpPr>
-          <p:cNvPr id="148" name="Google Shape;148;p9"/>
-          <p:cNvSpPr txBox="1">
-            <a:spLocks noGrp="1"/>
-          </p:cNvSpPr>
-          <p:nvPr>
-            <p:ph type="body" idx="1"/>
-          </p:nvPr>
-        </p:nvSpPr>
-        <p:spPr>
-          <a:xfrm>
-            <a:off x="548640" y="1051560"/>
-            <a:ext cx="11064240" cy="5486400"/>
-          </a:xfrm>
-          <a:prstGeom prst="rect">
-            <a:avLst/>
-          </a:prstGeom>
-          <a:noFill/>
-          <a:ln>
-            <a:noFill/>
-          </a:ln>
-        </p:spPr>
-        <p:txBody>
-          <a:bodyPr spcFirstLastPara="1" wrap="square" lIns="91425" tIns="45700" rIns="91425" bIns="45700" anchor="t" anchorCtr="0">
-            <a:normAutofit/>
-          </a:bodyPr>
-          <a:lstStyle/>
-          <a:p>
-            <a:pPr marL="201168" lvl="0" indent="-201168">
-              <a:spcBef>
-                <a:spcPts val="0"/>
-              </a:spcBef>
-              <a:spcAft>
-                <a:spcPts val="200"/>
-              </a:spcAft>
-              <a:buSzPts val="2800"/>
-              <a:buChar char="•"/>
-            </a:pPr>
-            <a:r>
-              <a:rPr sz="1900" b="1">
-                <a:solidFill>
-                  <a:srgbClr val="7030A0"/>
-                </a:solidFill>
-                <a:latin typeface="Calibri"/>
-              </a:rPr>
-              <a:t>Streaming ASR &amp; Entity Recognition</a:t>
-            </a:r>
-          </a:p>
-          <a:p>
-            <a:pPr marL="201168" indent="0">
-              <a:spcBef>
-                <a:spcPts val="0"/>
-              </a:spcBef>
-              <a:spcAft>
-                <a:spcPts val="200"/>
-              </a:spcAft>
-              <a:buNone/>
-            </a:pPr>
-            <a:r>
-              <a:rPr sz="1600">
-                <a:solidFill>
-                  <a:srgbClr val="000000"/>
-                </a:solidFill>
-                <a:latin typeface="Calibri"/>
-              </a:rPr>
-              <a:t>Speech-to-text is already hosted (gpt-4o-mini-transcribe). Next: a streaming ASR (NVIDIA Parakeet) for better proper nouns and lower latency.</a:t>
-            </a:r>
-          </a:p>
-          <a:p>
-            <a:pPr marL="201168" indent="0">
-              <a:spcBef>
-                <a:spcPts val="0"/>
-              </a:spcBef>
-              <a:spcAft>
-                <a:spcPts val="1300"/>
-              </a:spcAft>
-              <a:buNone/>
-            </a:pPr>
-            <a:r>
-              <a:rPr sz="1600" b="1" i="1">
-                <a:solidFill>
-                  <a:srgbClr val="704EA6"/>
-                </a:solidFill>
-                <a:latin typeface="Calibri"/>
-              </a:rPr>
-              <a:t>→ Fewer misheard cities and model numbers</a:t>
-            </a:r>
-          </a:p>
-          <a:p>
-            <a:pPr marL="201168" indent="-201168">
-              <a:spcBef>
-                <a:spcPts val="0"/>
-              </a:spcBef>
-              <a:spcAft>
-                <a:spcPts val="200"/>
-              </a:spcAft>
-              <a:buChar char="•"/>
-            </a:pPr>
-            <a:r>
-              <a:rPr sz="1900" b="1">
-                <a:solidFill>
-                  <a:srgbClr val="7030A0"/>
-                </a:solidFill>
-                <a:latin typeface="Calibri"/>
-              </a:rPr>
-              <a:t>Proactive Dialogue &amp; Multi-Slot Reasoning</a:t>
-            </a:r>
-          </a:p>
-          <a:p>
-            <a:pPr marL="201168" indent="0">
-              <a:spcBef>
-                <a:spcPts val="0"/>
-              </a:spcBef>
-              <a:spcAft>
-                <a:spcPts val="200"/>
-              </a:spcAft>
-              <a:buNone/>
-            </a:pPr>
-            <a:r>
-              <a:rPr sz="1600">
-                <a:solidFill>
-                  <a:srgbClr val="000000"/>
-                </a:solidFill>
-                <a:latin typeface="Calibri"/>
-              </a:rPr>
-              <a:t>Move from passive settle-time barriers to clarification dialogues ("I found two options, shall I book the 6 PM one?") and better handling of complex multi-constraint queries (Housing).</a:t>
-            </a:r>
-          </a:p>
-          <a:p>
-            <a:pPr marL="201168" indent="0">
-              <a:spcBef>
-                <a:spcPts val="0"/>
-              </a:spcBef>
-              <a:spcAft>
-                <a:spcPts val="1300"/>
-              </a:spcAft>
-              <a:buNone/>
-            </a:pPr>
-            <a:r>
-              <a:rPr sz="1600" b="1" i="1">
-                <a:solidFill>
-                  <a:srgbClr val="704EA6"/>
-                </a:solidFill>
-                <a:latin typeface="Calibri"/>
-              </a:rPr>
-              <a:t>→ Fewer wrong bookings on hard requests</a:t>
-            </a:r>
-          </a:p>
-          <a:p>
-            <a:pPr marL="201168" indent="-201168">
-              <a:spcBef>
-                <a:spcPts val="0"/>
-              </a:spcBef>
-              <a:spcAft>
-                <a:spcPts val="200"/>
-              </a:spcAft>
-              <a:buChar char="•"/>
-            </a:pPr>
-            <a:r>
-              <a:rPr sz="1900" b="1">
-                <a:solidFill>
-                  <a:srgbClr val="7030A0"/>
-                </a:solidFill>
-                <a:latin typeface="Calibri"/>
-              </a:rPr>
-              <a:t>Temporal Video Diagnostics</a:t>
-            </a:r>
-          </a:p>
-          <a:p>
-            <a:pPr marL="201168" indent="0">
-              <a:spcBef>
-                <a:spcPts val="0"/>
-              </a:spcBef>
-              <a:spcAft>
-                <a:spcPts val="200"/>
-              </a:spcAft>
-              <a:buNone/>
-            </a:pPr>
-            <a:r>
-              <a:rPr sz="1600">
-                <a:solidFill>
-                  <a:srgbClr val="000000"/>
-                </a:solidFill>
-                <a:latin typeface="Calibri"/>
-              </a:rPr>
-              <a:t>Upgrade from 1 fps still frames to multi-frame analysis to detect high-frequency blinking LED patterns and dynamic appliance states.</a:t>
-            </a:r>
-          </a:p>
-          <a:p>
-            <a:pPr marL="201168" indent="0">
-              <a:spcBef>
-                <a:spcPts val="0"/>
-              </a:spcBef>
-              <a:spcAft>
-                <a:spcPts val="1300"/>
-              </a:spcAft>
-              <a:buNone/>
-            </a:pPr>
-            <a:r>
-              <a:rPr sz="1600" b="1" i="1">
-                <a:solidFill>
-                  <a:srgbClr val="704EA6"/>
-                </a:solidFill>
-                <a:latin typeface="Calibri"/>
-              </a:rPr>
-              <a:t>→ Reads blinking-LED codes without a spoken cue</a:t>
-            </a:r>
-          </a:p>
-          <a:p>
-            <a:pPr marL="201168" indent="-201168">
-              <a:spcBef>
-                <a:spcPts val="0"/>
-              </a:spcBef>
-              <a:spcAft>
-                <a:spcPts val="200"/>
-              </a:spcAft>
-              <a:buChar char="•"/>
-            </a:pPr>
-            <a:r>
-              <a:rPr sz="1900" b="1">
-                <a:solidFill>
-                  <a:srgbClr val="7030A0"/>
-                </a:solidFill>
-                <a:latin typeface="Calibri"/>
-              </a:rPr>
-              <a:t>On-Device NPU Porting (Galaxy AI)</a:t>
-            </a:r>
-          </a:p>
-          <a:p>
-            <a:pPr marL="201168" indent="0">
-              <a:spcBef>
-                <a:spcPts val="0"/>
-              </a:spcBef>
-              <a:spcAft>
-                <a:spcPts val="200"/>
-              </a:spcAft>
-              <a:buNone/>
-            </a:pPr>
-            <a:r>
-              <a:rPr sz="1600">
-                <a:solidFill>
-                  <a:srgbClr val="000000"/>
-                </a:solidFill>
-                <a:latin typeface="Calibri"/>
-              </a:rPr>
-              <a:t>Port the lightweight synchronous kernel and local speech stack to Samsung Exynos / Snapdragon NPUs for offline, ultra-low-latency execution.</a:t>
-            </a:r>
-          </a:p>
-          <a:p>
-            <a:pPr marL="201168" indent="0">
-              <a:spcBef>
-                <a:spcPts val="0"/>
-              </a:spcBef>
-              <a:spcAft>
-                <a:spcPts val="1300"/>
-              </a:spcAft>
-              <a:buNone/>
-            </a:pPr>
-            <a:r>
-              <a:rPr sz="1600" b="1" i="1">
-                <a:solidFill>
-                  <a:srgbClr val="704EA6"/>
-                </a:solidFill>
-                <a:latin typeface="Calibri"/>
-              </a:rPr>
-              <a:t>→ Galaxy devices, offline</a:t>
-            </a:r>
-          </a:p>
-          <a:p>
-            <a:pPr marL="201168" indent="-201168">
-              <a:spcBef>
-                <a:spcPts val="0"/>
-              </a:spcBef>
-              <a:spcAft>
-                <a:spcPts val="200"/>
-              </a:spcAft>
-              <a:buChar char="•"/>
-            </a:pPr>
-            <a:r>
-              <a:rPr sz="1900" b="1">
-                <a:solidFill>
-                  <a:srgbClr val="7030A0"/>
-                </a:solidFill>
-                <a:latin typeface="Calibri"/>
-              </a:rPr>
-              <a:t>Production Samsung Ecosystem Bridge</a:t>
-            </a:r>
-          </a:p>
-          <a:p>
-            <a:pPr marL="201168" indent="0">
-              <a:spcBef>
-                <a:spcPts val="0"/>
-              </a:spcBef>
-              <a:spcAft>
-                <a:spcPts val="200"/>
-              </a:spcAft>
-              <a:buNone/>
-            </a:pPr>
-            <a:r>
-              <a:rPr sz="1600">
-                <a:solidFill>
-                  <a:srgbClr val="000000"/>
-                </a:solidFill>
-                <a:latin typeface="Calibri"/>
-              </a:rPr>
-              <a:t>Plug Samsung Gauss / Bixby in as the reasoning engine via the existing ModelGateway, plus direct SmartThings and Samsung Care+ APIs for live appliance telemetry, error-code lookup and automated technician dispatch.</a:t>
-            </a:r>
-          </a:p>
-          <a:p>
-            <a:pPr marL="201168" indent="0">
-              <a:spcBef>
-                <a:spcPts val="0"/>
-              </a:spcBef>
-              <a:spcAft>
-                <a:spcPts val="1300"/>
-              </a:spcAft>
-              <a:buNone/>
-            </a:pPr>
-            <a:r>
-              <a:rPr sz="1600" b="1" i="1">
-                <a:solidFill>
-                  <a:srgbClr val="704EA6"/>
-                </a:solidFill>
-                <a:latin typeface="Calibri"/>
-              </a:rPr>
-              <a:t>→ Real Samsung devices, real service tickets</a:t>
-            </a:r>
-          </a:p>
-        </p:txBody>
-      </p:sp>
-    </p:spTree>
-  </p:cSld>
-  <p:clrMapOvr>
-    <a:masterClrMapping/>
-  </p:clrMapOvr>
-</p:sld>
-</file>
-
 <file path=ppt/slides/slide2.xml><?xml version="1.0" encoding="utf-8"?>
 <p:sld xmlns:a="http://schemas.openxmlformats.org/drawingml/2006/main" xmlns:r="http://schemas.openxmlformats.org/officeDocument/2006/relationships" xmlns:p="http://schemas.openxmlformats.org/presentationml/2006/main">
   <p:cSld>
@@ -17157,7 +16725,7 @@
           <a:p>
             <a:pPr lvl="0"/>
             <a:r>
-              <a:rPr lang="en-US" b="1" dirty="0" sz="3200">
+              <a:rPr lang="en-US" sz="3200" b="1" dirty="0">
                 <a:solidFill>
                   <a:srgbClr val="704EA6"/>
                 </a:solidFill>
@@ -17309,25 +16877,55 @@
         </p:nvGraphicFramePr>
         <p:xfrm>
           <a:off x="548640" y="3520440"/>
-          <a:ext cx="11064240" cy="1371600"/>
+          <a:ext cx="11064240" cy="1563624"/>
         </p:xfrm>
         <a:graphic>
           <a:graphicData uri="http://schemas.openxmlformats.org/drawingml/2006/table">
             <a:tbl>
-              <a:tblPr firstRow="0" bandRow="0">
+              <a:tblPr>
                 <a:tableStyleId>{5C22544A-7EE6-4342-B048-85BDC9FD1C3A}</a:tableStyleId>
               </a:tblPr>
               <a:tblGrid>
-                <a:gridCol w="1737360"/>
-                <a:gridCol w="2331720"/>
-                <a:gridCol w="2331720"/>
-                <a:gridCol w="2331720"/>
-                <a:gridCol w="2331720"/>
+                <a:gridCol w="1737360">
+                  <a:extLst>
+                    <a:ext uri="{9D8B030D-6E8A-4147-A177-3AD203B41FA5}">
+                      <a16:colId xmlns:a16="http://schemas.microsoft.com/office/drawing/2014/main" val="20000"/>
+                    </a:ext>
+                  </a:extLst>
+                </a:gridCol>
+                <a:gridCol w="2331720">
+                  <a:extLst>
+                    <a:ext uri="{9D8B030D-6E8A-4147-A177-3AD203B41FA5}">
+                      <a16:colId xmlns:a16="http://schemas.microsoft.com/office/drawing/2014/main" val="20001"/>
+                    </a:ext>
+                  </a:extLst>
+                </a:gridCol>
+                <a:gridCol w="2331720">
+                  <a:extLst>
+                    <a:ext uri="{9D8B030D-6E8A-4147-A177-3AD203B41FA5}">
+                      <a16:colId xmlns:a16="http://schemas.microsoft.com/office/drawing/2014/main" val="20002"/>
+                    </a:ext>
+                  </a:extLst>
+                </a:gridCol>
+                <a:gridCol w="2331720">
+                  <a:extLst>
+                    <a:ext uri="{9D8B030D-6E8A-4147-A177-3AD203B41FA5}">
+                      <a16:colId xmlns:a16="http://schemas.microsoft.com/office/drawing/2014/main" val="20003"/>
+                    </a:ext>
+                  </a:extLst>
+                </a:gridCol>
+                <a:gridCol w="2331720">
+                  <a:extLst>
+                    <a:ext uri="{9D8B030D-6E8A-4147-A177-3AD203B41FA5}">
+                      <a16:colId xmlns:a16="http://schemas.microsoft.com/office/drawing/2014/main" val="20004"/>
+                    </a:ext>
+                  </a:extLst>
+                </a:gridCol>
               </a:tblGrid>
               <a:tr h="457200">
                 <a:tc>
                   <a:txBody>
-                    <a:bodyPr wrap="square"/>
+                    <a:bodyPr/>
                     <a:lstStyle/>
                     <a:p>
                       <a:pPr algn="ctr"/>
@@ -17350,7 +16948,7 @@
                 </a:tc>
                 <a:tc>
                   <a:txBody>
-                    <a:bodyPr wrap="square"/>
+                    <a:bodyPr/>
                     <a:lstStyle/>
                     <a:p>
                       <a:pPr algn="ctr"/>
@@ -17373,7 +16971,7 @@
                 </a:tc>
                 <a:tc>
                   <a:txBody>
-                    <a:bodyPr wrap="square"/>
+                    <a:bodyPr/>
                     <a:lstStyle/>
                     <a:p>
                       <a:pPr algn="ctr"/>
@@ -17396,7 +16994,7 @@
                 </a:tc>
                 <a:tc>
                   <a:txBody>
-                    <a:bodyPr wrap="square"/>
+                    <a:bodyPr/>
                     <a:lstStyle/>
                     <a:p>
                       <a:pPr algn="ctr"/>
@@ -17419,7 +17017,7 @@
                 </a:tc>
                 <a:tc>
                   <a:txBody>
-                    <a:bodyPr wrap="square"/>
+                    <a:bodyPr/>
                     <a:lstStyle/>
                     <a:p>
                       <a:pPr algn="ctr"/>
@@ -17440,11 +17038,16 @@
                     </a:solidFill>
                   </a:tcPr>
                 </a:tc>
+                <a:extLst>
+                  <a:ext uri="{0D108BD9-81ED-4DB2-BD59-A6C34878D82A}">
+                    <a16:rowId xmlns:a16="http://schemas.microsoft.com/office/drawing/2014/main" val="10000"/>
+                  </a:ext>
+                </a:extLst>
               </a:tr>
               <a:tr h="457200">
                 <a:tc>
                   <a:txBody>
-                    <a:bodyPr wrap="square"/>
+                    <a:bodyPr/>
                     <a:lstStyle/>
                     <a:p>
                       <a:pPr algn="l"/>
@@ -17467,7 +17070,7 @@
                 </a:tc>
                 <a:tc>
                   <a:txBody>
-                    <a:bodyPr wrap="square"/>
+                    <a:bodyPr/>
                     <a:lstStyle/>
                     <a:p>
                       <a:pPr algn="l"/>
@@ -17490,7 +17093,7 @@
                 </a:tc>
                 <a:tc>
                   <a:txBody>
-                    <a:bodyPr wrap="square"/>
+                    <a:bodyPr/>
                     <a:lstStyle/>
                     <a:p>
                       <a:pPr algn="l"/>
@@ -17513,7 +17116,7 @@
                 </a:tc>
                 <a:tc>
                   <a:txBody>
-                    <a:bodyPr wrap="square"/>
+                    <a:bodyPr/>
                     <a:lstStyle/>
                     <a:p>
                       <a:pPr algn="l"/>
@@ -17536,7 +17139,7 @@
                 </a:tc>
                 <a:tc>
                   <a:txBody>
-                    <a:bodyPr wrap="square"/>
+                    <a:bodyPr/>
                     <a:lstStyle/>
                     <a:p>
                       <a:pPr algn="l"/>
@@ -17557,11 +17160,16 @@
                     </a:solidFill>
                   </a:tcPr>
                 </a:tc>
+                <a:extLst>
+                  <a:ext uri="{0D108BD9-81ED-4DB2-BD59-A6C34878D82A}">
+                    <a16:rowId xmlns:a16="http://schemas.microsoft.com/office/drawing/2014/main" val="10001"/>
+                  </a:ext>
+                </a:extLst>
               </a:tr>
               <a:tr h="457200">
                 <a:tc>
                   <a:txBody>
-                    <a:bodyPr wrap="square"/>
+                    <a:bodyPr/>
                     <a:lstStyle/>
                     <a:p>
                       <a:pPr algn="l"/>
@@ -17584,7 +17192,7 @@
                 </a:tc>
                 <a:tc>
                   <a:txBody>
-                    <a:bodyPr wrap="square"/>
+                    <a:bodyPr/>
                     <a:lstStyle/>
                     <a:p>
                       <a:pPr algn="l"/>
@@ -17607,7 +17215,7 @@
                 </a:tc>
                 <a:tc>
                   <a:txBody>
-                    <a:bodyPr wrap="square"/>
+                    <a:bodyPr/>
                     <a:lstStyle/>
                     <a:p>
                       <a:pPr algn="l"/>
@@ -17630,7 +17238,7 @@
                 </a:tc>
                 <a:tc>
                   <a:txBody>
-                    <a:bodyPr wrap="square"/>
+                    <a:bodyPr/>
                     <a:lstStyle/>
                     <a:p>
                       <a:pPr algn="l"/>
@@ -17653,7 +17261,7 @@
                 </a:tc>
                 <a:tc>
                   <a:txBody>
-                    <a:bodyPr wrap="square"/>
+                    <a:bodyPr/>
                     <a:lstStyle/>
                     <a:p>
                       <a:pPr algn="l"/>
@@ -17674,6 +17282,11 @@
                     </a:solidFill>
                   </a:tcPr>
                 </a:tc>
+                <a:extLst>
+                  <a:ext uri="{0D108BD9-81ED-4DB2-BD59-A6C34878D82A}">
+                    <a16:rowId xmlns:a16="http://schemas.microsoft.com/office/drawing/2014/main" val="10002"/>
+                  </a:ext>
+                </a:extLst>
               </a:tr>
             </a:tbl>
           </a:graphicData>
@@ -17696,7 +17309,7 @@
           <a:noFill/>
         </p:spPr>
         <p:txBody>
-          <a:bodyPr wrap="square" lIns="45720" rIns="45720" tIns="27432" bIns="27432">
+          <a:bodyPr wrap="square" lIns="45720" tIns="27432" rIns="45720" bIns="27432">
             <a:spAutoFit/>
           </a:bodyPr>
           <a:lstStyle/>
@@ -17739,7 +17352,7 @@
 </p:sld>
 </file>
 
-<file path=ppt/slides/slide4.xml><?xml version="1.0" encoding="utf-8"?>
+<file path=ppt/slides/slide3.xml><?xml version="1.0" encoding="utf-8"?>
 <p:sld xmlns:a="http://schemas.openxmlformats.org/drawingml/2006/main" xmlns:r="http://schemas.openxmlformats.org/officeDocument/2006/relationships" xmlns:p="http://schemas.openxmlformats.org/presentationml/2006/main">
   <p:cSld>
     <p:bg>
@@ -17795,7 +17408,7 @@
           <a:p>
             <a:pPr lvl="0"/>
             <a:r>
-              <a:rPr lang="en-US" b="1" dirty="0" sz="3200">
+              <a:rPr lang="en-US" sz="3200" b="1" dirty="0">
                 <a:solidFill>
                   <a:srgbClr val="704EA6"/>
                 </a:solidFill>
@@ -17844,7 +17457,7 @@
               <a:buNone/>
             </a:pPr>
             <a:r>
-              <a:rPr sz="1800" b="1">
+              <a:rPr sz="1800" b="1" dirty="0">
                 <a:solidFill>
                   <a:srgbClr val="7030A0"/>
                 </a:solidFill>
@@ -17864,13 +17477,31 @@
               <a:buNone/>
             </a:pPr>
             <a:r>
-              <a:rPr sz="1600">
+              <a:rPr sz="1600" dirty="0">
                 <a:solidFill>
                   <a:srgbClr val="000000"/>
                 </a:solidFill>
                 <a:latin typeface="Calibri"/>
               </a:rPr>
-              <a:t>Janus solves the three-way concurrency problem with a deterministic 7-phase synchronous step engine (under 5 ms per step) paired with isolated async workers. All state changes happen inside a single-threaded kernel step, eliminating race conditions by design, not by luck.</a:t>
+              <a:t>Janus solves the three-way concurrency problem with a deterministic 7-phase synchronous step engine (under 5 </a:t>
+            </a:r>
+            <a:r>
+              <a:rPr sz="1600" dirty="0" err="1">
+                <a:solidFill>
+                  <a:srgbClr val="000000"/>
+                </a:solidFill>
+                <a:latin typeface="Calibri"/>
+              </a:rPr>
+              <a:t>ms</a:t>
+            </a:r>
+            <a:r>
+              <a:rPr sz="1600" dirty="0">
+                <a:solidFill>
+                  <a:srgbClr val="000000"/>
+                </a:solidFill>
+                <a:latin typeface="Calibri"/>
+              </a:rPr>
+              <a:t> per step) paired with isolated async workers. All state changes happen inside a single-threaded kernel step, eliminating race conditions by design, not by luck.</a:t>
             </a:r>
           </a:p>
           <a:p>
@@ -17884,7 +17515,7 @@
               <a:buNone/>
             </a:pPr>
             <a:r>
-              <a:rPr sz="1600">
+              <a:rPr sz="1600" dirty="0">
                 <a:solidFill>
                   <a:srgbClr val="000000"/>
                 </a:solidFill>
@@ -17892,9 +17523,32 @@
               </a:rPr>
               <a:t>Every event, whether a speech chunk, a tool result or a user interruption, passes through the same deterministic pipeline:</a:t>
             </a:r>
+            <a:endParaRPr lang="en-US" sz="1600" dirty="0">
+              <a:solidFill>
+                <a:srgbClr val="000000"/>
+              </a:solidFill>
+              <a:latin typeface="Calibri"/>
+            </a:endParaRPr>
           </a:p>
           <a:p>
-            <a:pPr algn="ctr" marL="0" indent="0">
+            <a:pPr marL="0" indent="0">
+              <a:spcBef>
+                <a:spcPts val="0"/>
+              </a:spcBef>
+              <a:spcAft>
+                <a:spcPts val="400"/>
+              </a:spcAft>
+              <a:buNone/>
+            </a:pPr>
+            <a:endParaRPr sz="1600" dirty="0">
+              <a:solidFill>
+                <a:srgbClr val="000000"/>
+              </a:solidFill>
+              <a:latin typeface="Calibri"/>
+            </a:endParaRPr>
+          </a:p>
+          <a:p>
+            <a:pPr marL="0" indent="0" algn="ctr">
               <a:spcBef>
                 <a:spcPts val="0"/>
               </a:spcBef>
@@ -17904,7 +17558,7 @@
               <a:buNone/>
             </a:pPr>
             <a:r>
-              <a:rPr sz="1800" b="1">
+              <a:rPr sz="1800" b="1" dirty="0">
                 <a:solidFill>
                   <a:srgbClr val="7030A0"/>
                 </a:solidFill>
@@ -17923,8 +17577,24 @@
               </a:spcAft>
               <a:buNone/>
             </a:pPr>
+            <a:br>
+              <a:rPr lang="en-US" sz="1800" b="1" dirty="0">
+                <a:solidFill>
+                  <a:srgbClr val="7030A0"/>
+                </a:solidFill>
+                <a:latin typeface="Calibri"/>
+              </a:rPr>
+            </a:br>
+            <a:br>
+              <a:rPr lang="en-US" sz="1800" b="1" dirty="0">
+                <a:solidFill>
+                  <a:srgbClr val="7030A0"/>
+                </a:solidFill>
+                <a:latin typeface="Calibri"/>
+              </a:rPr>
+            </a:br>
             <a:r>
-              <a:rPr sz="1800" b="1">
+              <a:rPr sz="1800" b="1" dirty="0">
                 <a:solidFill>
                   <a:srgbClr val="7030A0"/>
                 </a:solidFill>
@@ -17941,36 +17611,84 @@
           <p:cNvGraphicFramePr>
             <a:graphicFrameLocks noGrp="1"/>
           </p:cNvGraphicFramePr>
-          <p:nvPr/>
+          <p:nvPr>
+            <p:extLst>
+              <p:ext uri="{D42A27DB-BD31-4B8C-83A1-F6EECF244321}">
+                <p14:modId xmlns:p14="http://schemas.microsoft.com/office/powerpoint/2010/main" val="3142041627"/>
+              </p:ext>
+            </p:extLst>
+          </p:nvPr>
         </p:nvGraphicFramePr>
         <p:xfrm>
-          <a:off x="457200" y="3749039"/>
-          <a:ext cx="11247120" cy="1005840"/>
+          <a:off x="457200" y="4023360"/>
+          <a:ext cx="11247120" cy="1548384"/>
         </p:xfrm>
         <a:graphic>
           <a:graphicData uri="http://schemas.openxmlformats.org/drawingml/2006/table">
             <a:tbl>
-              <a:tblPr firstRow="0" bandRow="0">
+              <a:tblPr>
                 <a:tableStyleId>{5C22544A-7EE6-4342-B048-85BDC9FD1C3A}</a:tableStyleId>
               </a:tblPr>
               <a:tblGrid>
-                <a:gridCol w="1371600"/>
-                <a:gridCol w="1645920"/>
-                <a:gridCol w="1645920"/>
-                <a:gridCol w="1645920"/>
-                <a:gridCol w="1645920"/>
-                <a:gridCol w="1645920"/>
-                <a:gridCol w="1645920"/>
+                <a:gridCol w="1371600">
+                  <a:extLst>
+                    <a:ext uri="{9D8B030D-6E8A-4147-A177-3AD203B41FA5}">
+                      <a16:colId xmlns:a16="http://schemas.microsoft.com/office/drawing/2014/main" val="20000"/>
+                    </a:ext>
+                  </a:extLst>
+                </a:gridCol>
+                <a:gridCol w="1645920">
+                  <a:extLst>
+                    <a:ext uri="{9D8B030D-6E8A-4147-A177-3AD203B41FA5}">
+                      <a16:colId xmlns:a16="http://schemas.microsoft.com/office/drawing/2014/main" val="20001"/>
+                    </a:ext>
+                  </a:extLst>
+                </a:gridCol>
+                <a:gridCol w="1645920">
+                  <a:extLst>
+                    <a:ext uri="{9D8B030D-6E8A-4147-A177-3AD203B41FA5}">
+                      <a16:colId xmlns:a16="http://schemas.microsoft.com/office/drawing/2014/main" val="20002"/>
+                    </a:ext>
+                  </a:extLst>
+                </a:gridCol>
+                <a:gridCol w="1645920">
+                  <a:extLst>
+                    <a:ext uri="{9D8B030D-6E8A-4147-A177-3AD203B41FA5}">
+                      <a16:colId xmlns:a16="http://schemas.microsoft.com/office/drawing/2014/main" val="20003"/>
+                    </a:ext>
+                  </a:extLst>
+                </a:gridCol>
+                <a:gridCol w="1645920">
+                  <a:extLst>
+                    <a:ext uri="{9D8B030D-6E8A-4147-A177-3AD203B41FA5}">
+                      <a16:colId xmlns:a16="http://schemas.microsoft.com/office/drawing/2014/main" val="20004"/>
+                    </a:ext>
+                  </a:extLst>
+                </a:gridCol>
+                <a:gridCol w="1645920">
+                  <a:extLst>
+                    <a:ext uri="{9D8B030D-6E8A-4147-A177-3AD203B41FA5}">
+                      <a16:colId xmlns:a16="http://schemas.microsoft.com/office/drawing/2014/main" val="20005"/>
+                    </a:ext>
+                  </a:extLst>
+                </a:gridCol>
+                <a:gridCol w="1645920">
+                  <a:extLst>
+                    <a:ext uri="{9D8B030D-6E8A-4147-A177-3AD203B41FA5}">
+                      <a16:colId xmlns:a16="http://schemas.microsoft.com/office/drawing/2014/main" val="20006"/>
+                    </a:ext>
+                  </a:extLst>
+                </a:gridCol>
               </a:tblGrid>
               <a:tr h="502920">
                 <a:tc>
                   <a:txBody>
-                    <a:bodyPr wrap="square"/>
+                    <a:bodyPr/>
                     <a:lstStyle/>
                     <a:p>
                       <a:pPr algn="ctr"/>
                       <a:r>
-                        <a:rPr sz="1300" b="1">
+                        <a:rPr sz="1300" b="1" dirty="0">
                           <a:solidFill>
                             <a:srgbClr val="FFFFFF"/>
                           </a:solidFill>
@@ -17988,7 +17706,7 @@
                 </a:tc>
                 <a:tc>
                   <a:txBody>
-                    <a:bodyPr wrap="square"/>
+                    <a:bodyPr/>
                     <a:lstStyle/>
                     <a:p>
                       <a:pPr algn="ctr"/>
@@ -18011,7 +17729,7 @@
                 </a:tc>
                 <a:tc>
                   <a:txBody>
-                    <a:bodyPr wrap="square"/>
+                    <a:bodyPr/>
                     <a:lstStyle/>
                     <a:p>
                       <a:pPr algn="ctr"/>
@@ -18034,7 +17752,7 @@
                 </a:tc>
                 <a:tc>
                   <a:txBody>
-                    <a:bodyPr wrap="square"/>
+                    <a:bodyPr/>
                     <a:lstStyle/>
                     <a:p>
                       <a:pPr algn="ctr"/>
@@ -18057,7 +17775,7 @@
                 </a:tc>
                 <a:tc>
                   <a:txBody>
-                    <a:bodyPr wrap="square"/>
+                    <a:bodyPr/>
                     <a:lstStyle/>
                     <a:p>
                       <a:pPr algn="ctr"/>
@@ -18080,7 +17798,7 @@
                 </a:tc>
                 <a:tc>
                   <a:txBody>
-                    <a:bodyPr wrap="square"/>
+                    <a:bodyPr/>
                     <a:lstStyle/>
                     <a:p>
                       <a:pPr algn="ctr"/>
@@ -18103,7 +17821,7 @@
                 </a:tc>
                 <a:tc>
                   <a:txBody>
-                    <a:bodyPr wrap="square"/>
+                    <a:bodyPr/>
                     <a:lstStyle/>
                     <a:p>
                       <a:pPr algn="ctr"/>
@@ -18124,11 +17842,16 @@
                     </a:solidFill>
                   </a:tcPr>
                 </a:tc>
+                <a:extLst>
+                  <a:ext uri="{0D108BD9-81ED-4DB2-BD59-A6C34878D82A}">
+                    <a16:rowId xmlns:a16="http://schemas.microsoft.com/office/drawing/2014/main" val="10000"/>
+                  </a:ext>
+                </a:extLst>
               </a:tr>
               <a:tr h="502920">
                 <a:tc>
                   <a:txBody>
-                    <a:bodyPr wrap="square"/>
+                    <a:bodyPr/>
                     <a:lstStyle/>
                     <a:p>
                       <a:pPr algn="l"/>
@@ -18151,7 +17874,7 @@
                 </a:tc>
                 <a:tc>
                   <a:txBody>
-                    <a:bodyPr wrap="square"/>
+                    <a:bodyPr/>
                     <a:lstStyle/>
                     <a:p>
                       <a:pPr algn="l"/>
@@ -18174,18 +17897,36 @@
                 </a:tc>
                 <a:tc>
                   <a:txBody>
-                    <a:bodyPr wrap="square"/>
+                    <a:bodyPr/>
                     <a:lstStyle/>
                     <a:p>
                       <a:pPr algn="l"/>
                       <a:r>
-                        <a:rPr sz="1300" b="0">
+                        <a:rPr sz="1300" b="0" dirty="0">
                           <a:solidFill>
                             <a:srgbClr val="000000"/>
                           </a:solidFill>
                           <a:latin typeface="Calibri"/>
                         </a:rPr>
-                        <a:t>Fingerprinted, exactly-once writes: a duplicate (tool, args) is blocked.</a:t>
+                        <a:t>Fingerprinted, exactly-once writes: a duplicate (tool, </a:t>
+                      </a:r>
+                      <a:r>
+                        <a:rPr sz="1300" b="0" dirty="0" err="1">
+                          <a:solidFill>
+                            <a:srgbClr val="000000"/>
+                          </a:solidFill>
+                          <a:latin typeface="Calibri"/>
+                        </a:rPr>
+                        <a:t>args</a:t>
+                      </a:r>
+                      <a:r>
+                        <a:rPr sz="1300" b="0" dirty="0">
+                          <a:solidFill>
+                            <a:srgbClr val="000000"/>
+                          </a:solidFill>
+                          <a:latin typeface="Calibri"/>
+                        </a:rPr>
+                        <a:t>) is blocked.</a:t>
                       </a:r>
                     </a:p>
                   </a:txBody>
@@ -18197,7 +17938,7 @@
                 </a:tc>
                 <a:tc>
                   <a:txBody>
-                    <a:bodyPr wrap="square"/>
+                    <a:bodyPr/>
                     <a:lstStyle/>
                     <a:p>
                       <a:pPr algn="l"/>
@@ -18220,7 +17961,7 @@
                 </a:tc>
                 <a:tc>
                   <a:txBody>
-                    <a:bodyPr wrap="square"/>
+                    <a:bodyPr/>
                     <a:lstStyle/>
                     <a:p>
                       <a:pPr algn="l"/>
@@ -18243,7 +17984,7 @@
                 </a:tc>
                 <a:tc>
                   <a:txBody>
-                    <a:bodyPr wrap="square"/>
+                    <a:bodyPr/>
                     <a:lstStyle/>
                     <a:p>
                       <a:pPr algn="l"/>
@@ -18266,12 +18007,12 @@
                 </a:tc>
                 <a:tc>
                   <a:txBody>
-                    <a:bodyPr wrap="square"/>
+                    <a:bodyPr/>
                     <a:lstStyle/>
                     <a:p>
                       <a:pPr algn="l"/>
                       <a:r>
-                        <a:rPr sz="1300" b="0">
+                        <a:rPr sz="1300" b="0" dirty="0">
                           <a:solidFill>
                             <a:srgbClr val="000000"/>
                           </a:solidFill>
@@ -18287,6 +18028,11 @@
                     </a:solidFill>
                   </a:tcPr>
                 </a:tc>
+                <a:extLst>
+                  <a:ext uri="{0D108BD9-81ED-4DB2-BD59-A6C34878D82A}">
+                    <a16:rowId xmlns:a16="http://schemas.microsoft.com/office/drawing/2014/main" val="10001"/>
+                  </a:ext>
+                </a:extLst>
               </a:tr>
             </a:tbl>
           </a:graphicData>
@@ -18300,7 +18046,7 @@
 </p:sld>
 </file>
 
-<file path=ppt/slides/slide5.xml><?xml version="1.0" encoding="utf-8"?>
+<file path=ppt/slides/slide4.xml><?xml version="1.0" encoding="utf-8"?>
 <p:sld xmlns:a="http://schemas.openxmlformats.org/drawingml/2006/main" xmlns:r="http://schemas.openxmlformats.org/officeDocument/2006/relationships" xmlns:p="http://schemas.openxmlformats.org/presentationml/2006/main">
   <p:cSld>
     <p:spTree>
@@ -18348,7 +18094,7 @@
           <a:p>
             <a:pPr lvl="0"/>
             <a:r>
-              <a:rPr lang="en-US" b="1" dirty="0" sz="3000">
+              <a:rPr lang="en-US" sz="3000" b="1" dirty="0">
                 <a:solidFill>
                   <a:srgbClr val="704EA6"/>
                 </a:solidFill>
@@ -18361,7 +18107,13 @@
       </p:sp>
       <p:pic>
         <p:nvPicPr>
-          <p:cNvPr id="124" name="Picture 123" descr="1.jpg"/>
+          <p:cNvPr id="7" name="Picture 6">
+            <a:extLst>
+              <a:ext uri="{FF2B5EF4-FFF2-40B4-BE49-F238E27FC236}">
+                <a16:creationId xmlns:a16="http://schemas.microsoft.com/office/drawing/2014/main" id="{A75BC0BC-F4F0-5A52-611E-CB0E3F90E359}"/>
+              </a:ext>
+            </a:extLst>
+          </p:cNvPr>
           <p:cNvPicPr>
             <a:picLocks noChangeAspect="1"/>
           </p:cNvPicPr>
@@ -18375,8 +18127,8 @@
         </p:blipFill>
         <p:spPr>
           <a:xfrm>
-            <a:off x="1371447" y="1005840"/>
-            <a:ext cx="9448800" cy="5669280"/>
+            <a:off x="385922" y="1298448"/>
+            <a:ext cx="11420156" cy="4576780"/>
           </a:xfrm>
           <a:prstGeom prst="rect">
             <a:avLst/>
@@ -18391,751 +18143,7 @@
 </p:sld>
 </file>
 
-<file path=ppt/slides/slide7.xml><?xml version="1.0" encoding="utf-8"?>
-<p:sld xmlns:a="http://schemas.openxmlformats.org/drawingml/2006/main" xmlns:r="http://schemas.openxmlformats.org/officeDocument/2006/relationships" xmlns:p="http://schemas.openxmlformats.org/presentationml/2006/main">
-  <p:cSld>
-    <p:spTree>
-      <p:nvGrpSpPr>
-        <p:cNvPr id="1" name="Shape 134"/>
-        <p:cNvGrpSpPr/>
-        <p:nvPr/>
-      </p:nvGrpSpPr>
-      <p:grpSpPr>
-        <a:xfrm>
-          <a:off x="0" y="0"/>
-          <a:ext cx="0" cy="0"/>
-          <a:chOff x="0" y="0"/>
-          <a:chExt cx="0" cy="0"/>
-        </a:xfrm>
-      </p:grpSpPr>
-      <p:sp>
-        <p:nvSpPr>
-          <p:cNvPr id="135" name="Google Shape;135;p6"/>
-          <p:cNvSpPr txBox="1">
-            <a:spLocks noGrp="1"/>
-          </p:cNvSpPr>
-          <p:nvPr>
-            <p:ph type="title"/>
-          </p:nvPr>
-        </p:nvSpPr>
-        <p:spPr>
-          <a:xfrm>
-            <a:off x="457200" y="0"/>
-            <a:ext cx="11247120" cy="1325563"/>
-          </a:xfrm>
-          <a:prstGeom prst="rect">
-            <a:avLst/>
-          </a:prstGeom>
-          <a:noFill/>
-          <a:ln>
-            <a:noFill/>
-          </a:ln>
-        </p:spPr>
-        <p:txBody>
-          <a:bodyPr spcFirstLastPara="1" wrap="square" lIns="91425" tIns="45700" rIns="91425" bIns="45700" anchor="ctr" anchorCtr="0">
-            <a:normAutofit/>
-          </a:bodyPr>
-          <a:lstStyle/>
-          <a:p>
-            <a:pPr lvl="0"/>
-            <a:r>
-              <a:rPr lang="en-US" sz="2800" b="1" dirty="0">
-                <a:solidFill>
-                  <a:srgbClr val="704EA6"/>
-                </a:solidFill>
-              </a:rPr>
-              <a:t>Technology Stack</a:t>
-            </a:r>
-            <a:br>
-              <a:rPr lang="en-US" sz="2800" b="1" dirty="0">
-                <a:solidFill>
-                  <a:srgbClr val="704EA6"/>
-                </a:solidFill>
-              </a:rPr>
-            </a:br>
-            <a:endParaRPr sz="2500" b="1" dirty="0">
-              <a:solidFill>
-                <a:srgbClr val="0F172A"/>
-              </a:solidFill>
-            </a:endParaRPr>
-          </a:p>
-        </p:txBody>
-      </p:sp>
-      <p:sp>
-        <p:nvSpPr>
-          <p:cNvPr id="136" name="Google Shape;136;p6"/>
-          <p:cNvSpPr txBox="1">
-            <a:spLocks noGrp="1"/>
-          </p:cNvSpPr>
-          <p:nvPr>
-            <p:ph type="body" idx="1"/>
-          </p:nvPr>
-        </p:nvSpPr>
-        <p:spPr>
-          <a:xfrm>
-            <a:off x="706025" y="789600"/>
-            <a:ext cx="10515600" cy="5794080"/>
-          </a:xfrm>
-          <a:prstGeom prst="rect">
-            <a:avLst/>
-          </a:prstGeom>
-          <a:noFill/>
-          <a:ln>
-            <a:noFill/>
-          </a:ln>
-        </p:spPr>
-        <p:txBody>
-          <a:bodyPr spcFirstLastPara="1" wrap="square" lIns="91425" tIns="45700" rIns="91425" bIns="45700" anchor="t" anchorCtr="0">
-            <a:noAutofit/>
-          </a:bodyPr>
-          <a:lstStyle/>
-          <a:p>
-            <a:pPr marL="0" lvl="0" indent="0">
-              <a:spcBef>
-                <a:spcPts val="300"/>
-              </a:spcBef>
-              <a:spcAft>
-                <a:spcPts val="200"/>
-              </a:spcAft>
-              <a:buNone/>
-            </a:pPr>
-            <a:r>
-              <a:rPr lang="en-GB" sz="1500" b="1" dirty="0">
-                <a:solidFill>
-                  <a:srgbClr val="7030A0"/>
-                </a:solidFill>
-              </a:rPr>
-              <a:t>Core Kernel &amp; Coordination</a:t>
-            </a:r>
-          </a:p>
-          <a:p>
-            <a:pPr marL="0" lvl="0" indent="0">
-              <a:spcBef>
-                <a:spcPts val="300"/>
-              </a:spcBef>
-              <a:spcAft>
-                <a:spcPts val="200"/>
-              </a:spcAft>
-              <a:buNone/>
-            </a:pPr>
-            <a:r>
-              <a:rPr lang="en-GB" sz="1200" dirty="0">
-                <a:solidFill>
-                  <a:schemeClr val="tx1"/>
-                </a:solidFill>
-              </a:rPr>
-              <a:t>  • Runtime &amp; Language: Python 3.11 (compatible with 3.10–3.12)</a:t>
-            </a:r>
-          </a:p>
-          <a:p>
-            <a:pPr marL="0" lvl="0" indent="0">
-              <a:spcBef>
-                <a:spcPts val="300"/>
-              </a:spcBef>
-              <a:spcAft>
-                <a:spcPts val="200"/>
-              </a:spcAft>
-              <a:buNone/>
-            </a:pPr>
-            <a:r>
-              <a:rPr lang="en-GB" sz="1200" dirty="0">
-                <a:solidFill>
-                  <a:schemeClr val="tx1"/>
-                </a:solidFill>
-              </a:rPr>
-              <a:t>  • Data &amp; Schema Integrity: </a:t>
-            </a:r>
-            <a:r>
-              <a:rPr lang="en-GB" sz="1200" dirty="0" err="1">
-                <a:solidFill>
-                  <a:schemeClr val="tx1"/>
-                </a:solidFill>
-              </a:rPr>
-              <a:t>Pydantic</a:t>
-            </a:r>
-            <a:r>
-              <a:rPr lang="en-GB" sz="1200" dirty="0">
-                <a:solidFill>
-                  <a:schemeClr val="tx1"/>
-                </a:solidFill>
-              </a:rPr>
-              <a:t> v2.6+ (immutable state records, read-set validation), </a:t>
-            </a:r>
-            <a:r>
-              <a:rPr lang="en-GB" sz="1200" dirty="0" err="1">
-                <a:solidFill>
-                  <a:schemeClr val="tx1"/>
-                </a:solidFill>
-              </a:rPr>
-              <a:t>PyYAML</a:t>
-            </a:r>
-            <a:endParaRPr lang="en-GB" sz="1200" dirty="0">
-              <a:solidFill>
-                <a:schemeClr val="tx1"/>
-              </a:solidFill>
-            </a:endParaRPr>
-          </a:p>
-          <a:p>
-            <a:pPr marL="0" lvl="0" indent="0">
-              <a:spcBef>
-                <a:spcPts val="300"/>
-              </a:spcBef>
-              <a:spcAft>
-                <a:spcPts val="200"/>
-              </a:spcAft>
-              <a:buNone/>
-            </a:pPr>
-            <a:r>
-              <a:rPr lang="en-GB" sz="1200" dirty="0">
-                <a:solidFill>
-                  <a:schemeClr val="tx1"/>
-                </a:solidFill>
-              </a:rPr>
-              <a:t>  • Coordination Engine: Custom Single-Writer Synchronous Kernel (7-phase deterministic step, under 5 ms per step)</a:t>
-            </a:r>
-          </a:p>
-          <a:p>
-            <a:pPr marL="0" lvl="0" indent="0">
-              <a:spcBef>
-                <a:spcPts val="300"/>
-              </a:spcBef>
-              <a:spcAft>
-                <a:spcPts val="200"/>
-              </a:spcAft>
-              <a:buNone/>
-            </a:pPr>
-            <a:r>
-              <a:rPr lang="en-GB" sz="1200" dirty="0">
-                <a:solidFill>
-                  <a:schemeClr val="tx1"/>
-                </a:solidFill>
-              </a:rPr>
-              <a:t>  • Deterministic Clock: Stepped </a:t>
-            </a:r>
-            <a:r>
-              <a:rPr lang="en-GB" sz="1200" dirty="0" err="1">
-                <a:solidFill>
-                  <a:schemeClr val="tx1"/>
-                </a:solidFill>
-              </a:rPr>
-              <a:t>ClockPort</a:t>
-            </a:r>
-            <a:r>
-              <a:rPr lang="en-GB" sz="1200" dirty="0">
-                <a:solidFill>
-                  <a:schemeClr val="tx1"/>
-                </a:solidFill>
-              </a:rPr>
-              <a:t> (zero wall-clock dependencies; 100% byte-identical </a:t>
-            </a:r>
-            <a:r>
-              <a:rPr lang="en-GB" sz="1200" dirty="0" err="1">
-                <a:solidFill>
-                  <a:schemeClr val="tx1"/>
-                </a:solidFill>
-              </a:rPr>
-              <a:t>replayability</a:t>
-            </a:r>
-            <a:r>
-              <a:rPr lang="en-GB" sz="1200" dirty="0">
-                <a:solidFill>
-                  <a:schemeClr val="tx1"/>
-                </a:solidFill>
-              </a:rPr>
-              <a:t>)</a:t>
-            </a:r>
-          </a:p>
-          <a:p>
-            <a:pPr marL="0" lvl="0" indent="0">
-              <a:spcBef>
-                <a:spcPts val="300"/>
-              </a:spcBef>
-              <a:spcAft>
-                <a:spcPts val="200"/>
-              </a:spcAft>
-              <a:buNone/>
-            </a:pPr>
-            <a:r>
-              <a:rPr lang="en-GB" sz="1200" dirty="0">
-                <a:solidFill>
-                  <a:schemeClr val="tx1"/>
-                </a:solidFill>
-              </a:rPr>
-              <a:t>  </a:t>
-            </a:r>
-          </a:p>
-          <a:p>
-            <a:pPr marL="0" lvl="0" indent="0">
-              <a:spcBef>
-                <a:spcPts val="300"/>
-              </a:spcBef>
-              <a:spcAft>
-                <a:spcPts val="200"/>
-              </a:spcAft>
-              <a:buNone/>
-            </a:pPr>
-            <a:r>
-              <a:rPr lang="en-GB" sz="1200" b="1" dirty="0">
-                <a:solidFill>
-                  <a:srgbClr val="7030A0"/>
-                </a:solidFill>
-              </a:rPr>
-              <a:t>  </a:t>
-            </a:r>
-            <a:r>
-              <a:rPr lang="en-GB" sz="1500" b="1" dirty="0">
-                <a:solidFill>
-                  <a:srgbClr val="7030A0"/>
-                </a:solidFill>
-              </a:rPr>
-              <a:t>Real-Time Audio &amp; Vision Edge </a:t>
-            </a:r>
-          </a:p>
-          <a:p>
-            <a:pPr marL="0" lvl="0" indent="0">
-              <a:spcBef>
-                <a:spcPts val="300"/>
-              </a:spcBef>
-              <a:spcAft>
-                <a:spcPts val="200"/>
-              </a:spcAft>
-              <a:buNone/>
-            </a:pPr>
-            <a:r>
-              <a:rPr lang="en-GB" sz="1200" dirty="0">
-                <a:solidFill>
-                  <a:schemeClr val="tx1"/>
-                </a:solidFill>
-              </a:rPr>
-              <a:t>  • WebRTC &amp; Streaming: </a:t>
-            </a:r>
-            <a:r>
-              <a:rPr lang="en-GB" sz="1200" dirty="0" err="1">
-                <a:solidFill>
-                  <a:schemeClr val="tx1"/>
-                </a:solidFill>
-              </a:rPr>
-              <a:t>LiveKit</a:t>
-            </a:r>
-            <a:r>
-              <a:rPr lang="en-GB" sz="1200" dirty="0">
-                <a:solidFill>
-                  <a:schemeClr val="tx1"/>
-                </a:solidFill>
-              </a:rPr>
-              <a:t> Agents SDK v1.8.3 (</a:t>
-            </a:r>
-            <a:r>
-              <a:rPr lang="en-GB" sz="1200" dirty="0" err="1">
-                <a:solidFill>
-                  <a:schemeClr val="tx1"/>
-                </a:solidFill>
-              </a:rPr>
-              <a:t>livekit</a:t>
-            </a:r>
-            <a:r>
-              <a:rPr lang="en-GB" sz="1200" dirty="0">
-                <a:solidFill>
-                  <a:schemeClr val="tx1"/>
-                </a:solidFill>
-              </a:rPr>
-              <a:t>-agents)</a:t>
-            </a:r>
-          </a:p>
-          <a:p>
-            <a:pPr marL="0" lvl="0" indent="0">
-              <a:spcBef>
-                <a:spcPts val="300"/>
-              </a:spcBef>
-              <a:spcAft>
-                <a:spcPts val="200"/>
-              </a:spcAft>
-              <a:buNone/>
-            </a:pPr>
-            <a:r>
-              <a:rPr lang="en-GB" sz="1200" dirty="0">
-                <a:solidFill>
-                  <a:schemeClr val="tx1"/>
-                </a:solidFill>
-              </a:rPr>
-              <a:t>  • Voice Activity Detection (VAD): Silero VAD v5 (turn boundary and barge-in detection)</a:t>
-            </a:r>
-          </a:p>
-          <a:p>
-            <a:pPr marL="0" lvl="0" indent="0">
-              <a:spcBef>
-                <a:spcPts val="300"/>
-              </a:spcBef>
-              <a:spcAft>
-                <a:spcPts val="200"/>
-              </a:spcAft>
-              <a:buNone/>
-            </a:pPr>
-            <a:r>
-              <a:rPr lang="en-GB" sz="1200" dirty="0">
-                <a:solidFill>
-                  <a:schemeClr val="tx1"/>
-                </a:solidFill>
-              </a:rPr>
-              <a:t>  • Speech-to-Text (STT): OpenAI gpt-4o-mini-transcribe (default, pinned snapshot); faster-whisper large-v3-turbo on the GPU as a local option</a:t>
-            </a:r>
-          </a:p>
-          <a:p>
-            <a:pPr marL="0" lvl="0" indent="0">
-              <a:spcBef>
-                <a:spcPts val="300"/>
-              </a:spcBef>
-              <a:spcAft>
-                <a:spcPts val="200"/>
-              </a:spcAft>
-              <a:buNone/>
-            </a:pPr>
-            <a:r>
-              <a:rPr lang="en-GB" sz="1200" dirty="0">
-                <a:solidFill>
-                  <a:schemeClr val="tx1"/>
-                </a:solidFill>
-              </a:rPr>
-              <a:t>  • Text-to-Speech (TTS): Kokoro-82M v0.9.4 + Misaki + spaCy (instant low-latency neural synthesis)</a:t>
-            </a:r>
-          </a:p>
-          <a:p>
-            <a:pPr marL="0" lvl="0" indent="0">
-              <a:spcBef>
-                <a:spcPts val="300"/>
-              </a:spcBef>
-              <a:spcAft>
-                <a:spcPts val="200"/>
-              </a:spcAft>
-              <a:buNone/>
-            </a:pPr>
-            <a:r>
-              <a:rPr lang="en-GB" sz="1200" dirty="0">
-                <a:solidFill>
-                  <a:schemeClr val="tx1"/>
-                </a:solidFill>
-              </a:rPr>
-              <a:t>  • Vision Ingestion: WebRTC Video Sampler (1 fps JPEG extraction for multimodal grounding)</a:t>
-            </a:r>
-          </a:p>
-          <a:p>
-            <a:pPr marL="0" lvl="0" indent="0">
-              <a:spcBef>
-                <a:spcPts val="300"/>
-              </a:spcBef>
-              <a:spcAft>
-                <a:spcPts val="200"/>
-              </a:spcAft>
-              <a:buNone/>
-            </a:pPr>
-            <a:endParaRPr lang="en-GB" sz="1200" b="1" dirty="0">
-              <a:solidFill>
-                <a:srgbClr val="7030A0"/>
-              </a:solidFill>
-            </a:endParaRPr>
-          </a:p>
-          <a:p>
-            <a:pPr marL="0" lvl="0" indent="0">
-              <a:spcBef>
-                <a:spcPts val="300"/>
-              </a:spcBef>
-              <a:spcAft>
-                <a:spcPts val="200"/>
-              </a:spcAft>
-              <a:buNone/>
-            </a:pPr>
-            <a:r>
-              <a:rPr lang="en-GB" sz="1500" b="1" dirty="0">
-                <a:solidFill>
-                  <a:srgbClr val="7030A0"/>
-                </a:solidFill>
-              </a:rPr>
-              <a:t>Reasoning &amp; Foundation Models</a:t>
-            </a:r>
-          </a:p>
-          <a:p>
-            <a:pPr marL="0" lvl="0" indent="0">
-              <a:spcBef>
-                <a:spcPts val="300"/>
-              </a:spcBef>
-              <a:spcAft>
-                <a:spcPts val="200"/>
-              </a:spcAft>
-              <a:buNone/>
-            </a:pPr>
-            <a:r>
-              <a:rPr lang="en-GB" sz="1200" dirty="0">
-                <a:solidFill>
-                  <a:schemeClr val="tx1"/>
-                </a:solidFill>
-              </a:rPr>
-              <a:t>  • Decision &amp; Worker LLMs: Google Gemini 3.6 Flash / 3.5 Flash (hosted API, temperature=0, thinking budget 0)</a:t>
-            </a:r>
-          </a:p>
-          <a:p>
-            <a:pPr marL="0" lvl="0" indent="0">
-              <a:spcBef>
-                <a:spcPts val="300"/>
-              </a:spcBef>
-              <a:spcAft>
-                <a:spcPts val="200"/>
-              </a:spcAft>
-              <a:buNone/>
-            </a:pPr>
-            <a:r>
-              <a:rPr lang="en-GB" sz="1200" dirty="0">
-                <a:solidFill>
-                  <a:schemeClr val="tx1"/>
-                </a:solidFill>
-              </a:rPr>
-              <a:t>  • Async workers: Interpreter (intent), Planner / </a:t>
-            </a:r>
-            <a:r>
-              <a:rPr lang="en-GB" sz="1200" dirty="0" err="1">
-                <a:solidFill>
-                  <a:schemeClr val="tx1"/>
-                </a:solidFill>
-              </a:rPr>
-              <a:t>Rebinder</a:t>
-            </a:r>
-            <a:r>
-              <a:rPr lang="en-GB" sz="1200" dirty="0">
-                <a:solidFill>
-                  <a:schemeClr val="tx1"/>
-                </a:solidFill>
-              </a:rPr>
-              <a:t> (DAGs), Composer (grounded speech)</a:t>
-            </a:r>
-          </a:p>
-          <a:p>
-            <a:pPr marL="0" lvl="0" indent="0">
-              <a:spcBef>
-                <a:spcPts val="300"/>
-              </a:spcBef>
-              <a:spcAft>
-                <a:spcPts val="200"/>
-              </a:spcAft>
-              <a:buNone/>
-            </a:pPr>
-            <a:r>
-              <a:rPr lang="en-GB" sz="1200" dirty="0">
-                <a:solidFill>
-                  <a:schemeClr val="tx1"/>
-                </a:solidFill>
-              </a:rPr>
-              <a:t>  • Visual Reasoning: Gemini Multimodal Vision Worker (</a:t>
-            </a:r>
-            <a:r>
-              <a:rPr lang="en-GB" sz="1200" dirty="0" err="1">
-                <a:solidFill>
-                  <a:schemeClr val="tx1"/>
-                </a:solidFill>
-              </a:rPr>
-              <a:t>MediaPart</a:t>
-            </a:r>
-            <a:r>
-              <a:rPr lang="en-GB" sz="1200" dirty="0">
-                <a:solidFill>
-                  <a:schemeClr val="tx1"/>
-                </a:solidFill>
-              </a:rPr>
-              <a:t> / </a:t>
-            </a:r>
-            <a:r>
-              <a:rPr lang="en-GB" sz="1200" dirty="0" err="1">
-                <a:solidFill>
-                  <a:schemeClr val="tx1"/>
-                </a:solidFill>
-              </a:rPr>
-              <a:t>blob_resolver</a:t>
-            </a:r>
-            <a:r>
-              <a:rPr lang="en-GB" sz="1200" dirty="0">
-                <a:solidFill>
-                  <a:schemeClr val="tx1"/>
-                </a:solidFill>
-              </a:rPr>
-              <a:t>)</a:t>
-            </a:r>
-          </a:p>
-          <a:p>
-            <a:pPr marL="0" lvl="0" indent="0">
-              <a:spcBef>
-                <a:spcPts val="300"/>
-              </a:spcBef>
-              <a:spcAft>
-                <a:spcPts val="200"/>
-              </a:spcAft>
-              <a:buNone/>
-            </a:pPr>
-            <a:r>
-              <a:rPr lang="en-GB" sz="1200" dirty="0">
-                <a:solidFill>
-                  <a:schemeClr val="tx1"/>
-                </a:solidFill>
-              </a:rPr>
-              <a:t>  • Domain Tools &amp; Extensions: FDB-v3 Domain APIs (Finance, Travel, E-Commerce, Housing) + Device Care Diagnostic Tools</a:t>
-            </a:r>
-          </a:p>
-          <a:p>
-            <a:pPr marL="0" lvl="0" indent="0">
-              <a:spcBef>
-                <a:spcPts val="300"/>
-              </a:spcBef>
-              <a:spcAft>
-                <a:spcPts val="200"/>
-              </a:spcAft>
-              <a:buNone/>
-            </a:pPr>
-            <a:endParaRPr lang="en-GB" sz="1200" dirty="0">
-              <a:solidFill>
-                <a:schemeClr val="tx1"/>
-              </a:solidFill>
-            </a:endParaRPr>
-          </a:p>
-          <a:p>
-            <a:pPr marL="0" lvl="0" indent="0">
-              <a:spcBef>
-                <a:spcPts val="300"/>
-              </a:spcBef>
-              <a:spcAft>
-                <a:spcPts val="200"/>
-              </a:spcAft>
-              <a:buNone/>
-            </a:pPr>
-            <a:r>
-              <a:rPr lang="en-GB" sz="1500" b="1" dirty="0">
-                <a:solidFill>
-                  <a:srgbClr val="7030A0"/>
-                </a:solidFill>
-              </a:rPr>
-              <a:t>Benchmark, Testing &amp; Infrastructure</a:t>
-            </a:r>
-          </a:p>
-          <a:p>
-            <a:pPr marL="0" lvl="0" indent="0">
-              <a:spcBef>
-                <a:spcPts val="300"/>
-              </a:spcBef>
-              <a:spcAft>
-                <a:spcPts val="200"/>
-              </a:spcAft>
-              <a:buNone/>
-            </a:pPr>
-            <a:r>
-              <a:rPr lang="en-GB" sz="1200" dirty="0">
-                <a:solidFill>
-                  <a:schemeClr val="tx1"/>
-                </a:solidFill>
-              </a:rPr>
-              <a:t>  • Primary Benchmark: Full-Duplex-Bench v3 (FDB-v3) + NVIDIA Parakeet-TDT 0.6B (</a:t>
-            </a:r>
-            <a:r>
-              <a:rPr lang="en-GB" sz="1200" dirty="0" err="1">
-                <a:solidFill>
-                  <a:schemeClr val="tx1"/>
-                </a:solidFill>
-              </a:rPr>
-              <a:t>NeMo</a:t>
-            </a:r>
-            <a:r>
-              <a:rPr lang="en-GB" sz="1200" dirty="0">
-                <a:solidFill>
-                  <a:schemeClr val="tx1"/>
-                </a:solidFill>
-              </a:rPr>
-              <a:t> ASR scorer)</a:t>
-            </a:r>
-          </a:p>
-          <a:p>
-            <a:pPr marL="0" lvl="0" indent="0">
-              <a:spcBef>
-                <a:spcPts val="300"/>
-              </a:spcBef>
-              <a:spcAft>
-                <a:spcPts val="200"/>
-              </a:spcAft>
-              <a:buNone/>
-            </a:pPr>
-            <a:r>
-              <a:rPr lang="en-GB" sz="1200" dirty="0">
-                <a:solidFill>
-                  <a:schemeClr val="tx1"/>
-                </a:solidFill>
-              </a:rPr>
-              <a:t>  • Evaluation Judge: OpenAI GPT-4o (semantic argument &amp; response quality evaluation)</a:t>
-            </a:r>
-          </a:p>
-          <a:p>
-            <a:pPr marL="0" lvl="0" indent="0">
-              <a:spcBef>
-                <a:spcPts val="300"/>
-              </a:spcBef>
-              <a:spcAft>
-                <a:spcPts val="200"/>
-              </a:spcAft>
-              <a:buNone/>
-            </a:pPr>
-            <a:r>
-              <a:rPr lang="en-GB" sz="1200" dirty="0">
-                <a:solidFill>
-                  <a:schemeClr val="tx1"/>
-                </a:solidFill>
-              </a:rPr>
-              <a:t>  • Verification &amp; Testing: pytest (499 deterministic tests) + TraceChecker (commit gate &amp; floor rule audits)</a:t>
-            </a:r>
-          </a:p>
-          <a:p>
-            <a:pPr marL="0" lvl="0" indent="0">
-              <a:spcBef>
-                <a:spcPts val="300"/>
-              </a:spcBef>
-              <a:spcAft>
-                <a:spcPts val="200"/>
-              </a:spcAft>
-              <a:buNone/>
-            </a:pPr>
-            <a:r>
-              <a:rPr lang="en-GB" sz="1200" dirty="0">
-                <a:solidFill>
-                  <a:schemeClr val="tx1"/>
-                </a:solidFill>
-              </a:rPr>
-              <a:t>  • Deployment &amp; Containerization: Docker (</a:t>
-            </a:r>
-            <a:r>
-              <a:rPr lang="en-GB" sz="1200" dirty="0" err="1">
-                <a:solidFill>
-                  <a:schemeClr val="tx1"/>
-                </a:solidFill>
-              </a:rPr>
-              <a:t>nvidia</a:t>
-            </a:r>
-            <a:r>
-              <a:rPr lang="en-GB" sz="1200" dirty="0">
-                <a:solidFill>
-                  <a:schemeClr val="tx1"/>
-                </a:solidFill>
-              </a:rPr>
-              <a:t>/cuda:12.4.1, PyTorch v2.14 / CUDA 12.6) + ./reproduce.sh (one-command SHA-256 verified build &amp; run)</a:t>
-            </a:r>
-            <a:endParaRPr sz="1200" dirty="0">
-              <a:solidFill>
-                <a:schemeClr val="tx1"/>
-              </a:solidFill>
-            </a:endParaRPr>
-          </a:p>
-        </p:txBody>
-      </p:sp>
-    </p:spTree>
-  </p:cSld>
-  <p:clrMapOvr>
-    <a:masterClrMapping/>
-  </p:clrMapOvr>
-</p:sld>
-</file>
-
-<file path=ppt/slides/slide8.xml><?xml version="1.0" encoding="utf-8"?>
+<file path=ppt/slides/slide5.xml><?xml version="1.0" encoding="utf-8"?>
 <p:sld xmlns:a="http://schemas.openxmlformats.org/drawingml/2006/main" xmlns:r="http://schemas.openxmlformats.org/officeDocument/2006/relationships" xmlns:p="http://schemas.openxmlformats.org/presentationml/2006/main">
   <p:cSld>
     <p:spTree>
@@ -19195,7 +18203,7 @@
           <a:p>
             <a:pPr lvl="0"/>
             <a:r>
-              <a:rPr lang="en-US" b="1" dirty="0" sz="2800">
+              <a:rPr lang="en-US" sz="2800" b="1" dirty="0">
                 <a:solidFill>
                   <a:srgbClr val="704EA6"/>
                 </a:solidFill>
@@ -19241,7 +18249,7 @@
         </p:spPr>
         <p:txBody>
           <a:bodyPr spcFirstLastPara="1" wrap="square" lIns="91425" tIns="45700" rIns="91425" bIns="45700" anchor="t" anchorCtr="0">
-            <a:normAutofit/>
+            <a:normAutofit lnSpcReduction="10000"/>
           </a:bodyPr>
           <a:lstStyle/>
           <a:p>
@@ -19531,7 +18539,7 @@
 </p:sld>
 </file>
 
-<file path=ppt/slides/slide9.xml><?xml version="1.0" encoding="utf-8"?>
+<file path=ppt/slides/slide6.xml><?xml version="1.0" encoding="utf-8"?>
 <p:sld xmlns:a="http://schemas.openxmlformats.org/drawingml/2006/main" xmlns:r="http://schemas.openxmlformats.org/officeDocument/2006/relationships" xmlns:p="http://schemas.openxmlformats.org/presentationml/2006/main">
   <p:cSld>
     <p:spTree>
@@ -19579,7 +18587,7 @@
           <a:p>
             <a:pPr lvl="0"/>
             <a:r>
-              <a:rPr lang="en-US" b="1" dirty="0" sz="3200">
+              <a:rPr lang="en-US" sz="3200" b="1" dirty="0">
                 <a:solidFill>
                   <a:srgbClr val="704EA6"/>
                 </a:solidFill>
@@ -19615,7 +18623,7 @@
         </p:spPr>
         <p:txBody>
           <a:bodyPr spcFirstLastPara="1" wrap="square" lIns="91425" tIns="45700" rIns="91425" bIns="45700" anchor="t" anchorCtr="0">
-            <a:normAutofit fontScale="62500" lnSpcReduction="20000"/>
+            <a:normAutofit fontScale="92500" lnSpcReduction="10000"/>
           </a:bodyPr>
           <a:lstStyle/>
           <a:p>
@@ -19630,7 +18638,7 @@
               <a:buNone/>
             </a:pPr>
             <a:r>
-              <a:rPr sz="1400" b="1">
+              <a:rPr sz="1400" b="1" dirty="0">
                 <a:solidFill>
                   <a:srgbClr val="7030A0"/>
                 </a:solidFill>
@@ -19650,16 +18658,34 @@
               <a:buChar char="•"/>
             </a:pPr>
             <a:r>
-              <a:rPr sz="1150" b="1">
+              <a:rPr sz="1400" b="1" dirty="0">
                 <a:solidFill>
                   <a:srgbClr val="7030A0"/>
                 </a:solidFill>
                 <a:latin typeface="Calibri"/>
               </a:rPr>
-              <a:t>Single-writer safety kernel (under 5 ms per step). </a:t>
+              <a:t>Single-writer safety kernel (under 5 </a:t>
             </a:r>
             <a:r>
-              <a:rPr sz="1150">
+              <a:rPr sz="1400" b="1" dirty="0" err="1">
+                <a:solidFill>
+                  <a:srgbClr val="7030A0"/>
+                </a:solidFill>
+                <a:latin typeface="Calibri"/>
+              </a:rPr>
+              <a:t>ms</a:t>
+            </a:r>
+            <a:r>
+              <a:rPr sz="1400" b="1" dirty="0">
+                <a:solidFill>
+                  <a:srgbClr val="7030A0"/>
+                </a:solidFill>
+                <a:latin typeface="Calibri"/>
+              </a:rPr>
+              <a:t> per step). </a:t>
+            </a:r>
+            <a:r>
+              <a:rPr sz="1400" dirty="0">
                 <a:solidFill>
                   <a:srgbClr val="000000"/>
                 </a:solidFill>
@@ -19667,6 +18693,29 @@
               </a:rPr>
               <a:t>Models only propose; a synchronous kernel arbitrates every state change and tool call.</a:t>
             </a:r>
+            <a:endParaRPr lang="en-US" sz="1400" dirty="0">
+              <a:solidFill>
+                <a:srgbClr val="000000"/>
+              </a:solidFill>
+              <a:latin typeface="Calibri"/>
+            </a:endParaRPr>
+          </a:p>
+          <a:p>
+            <a:pPr marL="0" indent="0">
+              <a:spcBef>
+                <a:spcPts val="0"/>
+              </a:spcBef>
+              <a:spcAft>
+                <a:spcPts val="500"/>
+              </a:spcAft>
+              <a:buNone/>
+            </a:pPr>
+            <a:endParaRPr sz="1400" dirty="0">
+              <a:solidFill>
+                <a:srgbClr val="000000"/>
+              </a:solidFill>
+              <a:latin typeface="Calibri"/>
+            </a:endParaRPr>
           </a:p>
           <a:p>
             <a:pPr marL="201168" indent="-201168">
@@ -19679,7 +18728,7 @@
               <a:buChar char="•"/>
             </a:pPr>
             <a:r>
-              <a:rPr sz="1150" b="1">
+              <a:rPr sz="1400" b="1" dirty="0">
                 <a:solidFill>
                   <a:srgbClr val="7030A0"/>
                 </a:solidFill>
@@ -19688,7 +18737,7 @@
               <a:t>Same-step cancellation with read sets. </a:t>
             </a:r>
             <a:r>
-              <a:rPr sz="1150">
+              <a:rPr sz="1400" dirty="0">
                 <a:solidFill>
                   <a:srgbClr val="000000"/>
                 </a:solidFill>
@@ -19696,6 +18745,29 @@
               </a:rPr>
               <a:t>Every result records the (fact, version, digest) it read; if one changes, that work is cancelled in the same step.</a:t>
             </a:r>
+            <a:endParaRPr lang="en-US" sz="1400" dirty="0">
+              <a:solidFill>
+                <a:srgbClr val="000000"/>
+              </a:solidFill>
+              <a:latin typeface="Calibri"/>
+            </a:endParaRPr>
+          </a:p>
+          <a:p>
+            <a:pPr marL="0" indent="0">
+              <a:spcBef>
+                <a:spcPts val="0"/>
+              </a:spcBef>
+              <a:spcAft>
+                <a:spcPts val="500"/>
+              </a:spcAft>
+              <a:buNone/>
+            </a:pPr>
+            <a:endParaRPr sz="1400" dirty="0">
+              <a:solidFill>
+                <a:srgbClr val="000000"/>
+              </a:solidFill>
+              <a:latin typeface="Calibri"/>
+            </a:endParaRPr>
           </a:p>
           <a:p>
             <a:pPr marL="201168" indent="-201168">
@@ -19708,16 +18780,25 @@
               <a:buChar char="•"/>
             </a:pPr>
             <a:r>
-              <a:rPr sz="1150" b="1">
+              <a:rPr sz="1400" b="1" dirty="0" err="1">
                 <a:solidFill>
                   <a:srgbClr val="7030A0"/>
                 </a:solidFill>
                 <a:latin typeface="Calibri"/>
               </a:rPr>
-              <a:t>CommitGate (G1–G11) and settle window. </a:t>
+              <a:t>CommitGate</a:t>
             </a:r>
             <a:r>
-              <a:rPr sz="1150">
+              <a:rPr sz="1400" b="1" dirty="0">
+                <a:solidFill>
+                  <a:srgbClr val="7030A0"/>
+                </a:solidFill>
+                <a:latin typeface="Calibri"/>
+              </a:rPr>
+              <a:t> (G1–G11) and settle window. </a:t>
+            </a:r>
+            <a:r>
+              <a:rPr sz="1400" dirty="0">
                 <a:solidFill>
                   <a:srgbClr val="000000"/>
                 </a:solidFill>
@@ -19725,6 +18806,29 @@
               </a:rPr>
               <a:t>Separates speculative reads from irreversible writes, so each write happens exactly once.</a:t>
             </a:r>
+            <a:endParaRPr lang="en-US" sz="1400" dirty="0">
+              <a:solidFill>
+                <a:srgbClr val="000000"/>
+              </a:solidFill>
+              <a:latin typeface="Calibri"/>
+            </a:endParaRPr>
+          </a:p>
+          <a:p>
+            <a:pPr marL="0" indent="0">
+              <a:spcBef>
+                <a:spcPts val="0"/>
+              </a:spcBef>
+              <a:spcAft>
+                <a:spcPts val="500"/>
+              </a:spcAft>
+              <a:buNone/>
+            </a:pPr>
+            <a:endParaRPr sz="1400" dirty="0">
+              <a:solidFill>
+                <a:srgbClr val="000000"/>
+              </a:solidFill>
+              <a:latin typeface="Calibri"/>
+            </a:endParaRPr>
           </a:p>
           <a:p>
             <a:pPr marL="201168" indent="-201168">
@@ -19737,7 +18841,7 @@
               <a:buChar char="•"/>
             </a:pPr>
             <a:r>
-              <a:rPr sz="1150" b="1">
+              <a:rPr sz="1400" b="1" dirty="0">
                 <a:solidFill>
                   <a:srgbClr val="7030A0"/>
                 </a:solidFill>
@@ -19746,7 +18850,7 @@
               <a:t>Speculative interpretation and floor rule. </a:t>
             </a:r>
             <a:r>
-              <a:rPr sz="1150">
+              <a:rPr sz="1400" dirty="0">
                 <a:solidFill>
                   <a:srgbClr val="000000"/>
                 </a:solidFill>
@@ -19754,6 +18858,29 @@
               </a:rPr>
               <a:t>Pre-interprets speech while the user talks, with zero added latency when the prediction holds.</a:t>
             </a:r>
+            <a:endParaRPr lang="en-US" sz="1400" dirty="0">
+              <a:solidFill>
+                <a:srgbClr val="000000"/>
+              </a:solidFill>
+              <a:latin typeface="Calibri"/>
+            </a:endParaRPr>
+          </a:p>
+          <a:p>
+            <a:pPr marL="0" indent="0">
+              <a:spcBef>
+                <a:spcPts val="0"/>
+              </a:spcBef>
+              <a:spcAft>
+                <a:spcPts val="500"/>
+              </a:spcAft>
+              <a:buNone/>
+            </a:pPr>
+            <a:endParaRPr sz="1400" dirty="0">
+              <a:solidFill>
+                <a:srgbClr val="000000"/>
+              </a:solidFill>
+              <a:latin typeface="Calibri"/>
+            </a:endParaRPr>
           </a:p>
           <a:p>
             <a:pPr marL="201168" indent="-201168">
@@ -19766,7 +18893,7 @@
               <a:buChar char="•"/>
             </a:pPr>
             <a:r>
-              <a:rPr sz="1150" b="1">
+              <a:rPr sz="1400" b="1" dirty="0">
                 <a:solidFill>
                   <a:srgbClr val="7030A0"/>
                 </a:solidFill>
@@ -19775,7 +18902,7 @@
               <a:t>Deterministic replay and automated invariant checks. </a:t>
             </a:r>
             <a:r>
-              <a:rPr sz="1150">
+              <a:rPr sz="1400" dirty="0">
                 <a:solidFill>
                   <a:srgbClr val="000000"/>
                 </a:solidFill>
@@ -19783,6 +18910,29 @@
               </a:rPr>
               <a:t>A stepped virtual clock gives byte-identical replays, audited by the trace checker.</a:t>
             </a:r>
+            <a:endParaRPr lang="en-US" sz="1400" dirty="0">
+              <a:solidFill>
+                <a:srgbClr val="000000"/>
+              </a:solidFill>
+              <a:latin typeface="Calibri"/>
+            </a:endParaRPr>
+          </a:p>
+          <a:p>
+            <a:pPr marL="0" indent="0">
+              <a:spcBef>
+                <a:spcPts val="0"/>
+              </a:spcBef>
+              <a:spcAft>
+                <a:spcPts val="500"/>
+              </a:spcAft>
+              <a:buNone/>
+            </a:pPr>
+            <a:endParaRPr sz="1400" dirty="0">
+              <a:solidFill>
+                <a:srgbClr val="000000"/>
+              </a:solidFill>
+              <a:latin typeface="Calibri"/>
+            </a:endParaRPr>
           </a:p>
           <a:p>
             <a:pPr marL="201168" indent="-201168">
@@ -19795,7 +18945,7 @@
               <a:buChar char="•"/>
             </a:pPr>
             <a:r>
-              <a:rPr sz="1150" b="1">
+              <a:rPr sz="1400" b="1" dirty="0">
                 <a:solidFill>
                   <a:srgbClr val="7030A0"/>
                 </a:solidFill>
@@ -19804,7 +18954,7 @@
               <a:t>Camera-grounded multimodal safety. </a:t>
             </a:r>
             <a:r>
-              <a:rPr sz="1150">
+              <a:rPr sz="1400" dirty="0">
                 <a:solidFill>
                   <a:srgbClr val="000000"/>
                 </a:solidFill>
@@ -19854,10 +19004,10 @@
           </a:fontRef>
         </p:style>
         <p:txBody>
-          <a:bodyPr rtlCol="0" anchor="ctr" wrap="square"/>
+          <a:bodyPr wrap="square" rtlCol="0" anchor="ctr"/>
           <a:lstStyle/>
           <a:p>
-            <a:pPr algn="ctr" marL="0" indent="0">
+            <a:pPr marL="0" indent="0" algn="ctr">
               <a:spcBef>
                 <a:spcPts val="0"/>
               </a:spcBef>
@@ -19867,17 +19017,32 @@
               <a:buNone/>
             </a:pPr>
             <a:r>
-              <a:rPr sz="4800" b="1">
+              <a:rPr sz="4800" b="1" dirty="0">
                 <a:solidFill>
                   <a:srgbClr val="FFFFFF"/>
                 </a:solidFill>
                 <a:latin typeface="Calibri"/>
               </a:rPr>
-              <a:t>0.412</a:t>
+              <a:t>0.</a:t>
             </a:r>
+            <a:r>
+              <a:rPr lang="en-US" sz="4800" b="1" dirty="0">
+                <a:solidFill>
+                  <a:srgbClr val="FFFFFF"/>
+                </a:solidFill>
+                <a:latin typeface="Calibri"/>
+              </a:rPr>
+              <a:t>765</a:t>
+            </a:r>
+            <a:endParaRPr sz="4800" b="1" dirty="0">
+              <a:solidFill>
+                <a:srgbClr val="FFFFFF"/>
+              </a:solidFill>
+              <a:latin typeface="Calibri"/>
+            </a:endParaRPr>
           </a:p>
           <a:p>
-            <a:pPr algn="ctr" marL="0" indent="0">
+            <a:pPr marL="0" indent="0" algn="ctr">
               <a:spcBef>
                 <a:spcPts val="0"/>
               </a:spcBef>
@@ -19887,7 +19052,7 @@
               <a:buNone/>
             </a:pPr>
             <a:r>
-              <a:rPr sz="1100">
+              <a:rPr sz="1100" dirty="0">
                 <a:solidFill>
                   <a:srgbClr val="FFFFFF"/>
                 </a:solidFill>
@@ -19904,7 +19069,13 @@
           <p:cNvGraphicFramePr>
             <a:graphicFrameLocks noGrp="1"/>
           </p:cNvGraphicFramePr>
-          <p:nvPr/>
+          <p:nvPr>
+            <p:extLst>
+              <p:ext uri="{D42A27DB-BD31-4B8C-83A1-F6EECF244321}">
+                <p14:modId xmlns:p14="http://schemas.microsoft.com/office/powerpoint/2010/main" val="1606408458"/>
+              </p:ext>
+            </p:extLst>
+          </p:nvPr>
         </p:nvGraphicFramePr>
         <p:xfrm>
           <a:off x="7269480" y="1005840"/>
@@ -19913,17 +19084,29 @@
         <a:graphic>
           <a:graphicData uri="http://schemas.openxmlformats.org/drawingml/2006/table">
             <a:tbl>
-              <a:tblPr firstRow="0" bandRow="0">
+              <a:tblPr>
                 <a:tableStyleId>{5C22544A-7EE6-4342-B048-85BDC9FD1C3A}</a:tableStyleId>
               </a:tblPr>
               <a:tblGrid>
-                <a:gridCol w="2834640"/>
-                <a:gridCol w="1645920"/>
+                <a:gridCol w="2834640">
+                  <a:extLst>
+                    <a:ext uri="{9D8B030D-6E8A-4147-A177-3AD203B41FA5}">
+                      <a16:colId xmlns:a16="http://schemas.microsoft.com/office/drawing/2014/main" val="20000"/>
+                    </a:ext>
+                  </a:extLst>
+                </a:gridCol>
+                <a:gridCol w="1645920">
+                  <a:extLst>
+                    <a:ext uri="{9D8B030D-6E8A-4147-A177-3AD203B41FA5}">
+                      <a16:colId xmlns:a16="http://schemas.microsoft.com/office/drawing/2014/main" val="20001"/>
+                    </a:ext>
+                  </a:extLst>
+                </a:gridCol>
               </a:tblGrid>
               <a:tr h="274320">
                 <a:tc>
                   <a:txBody>
-                    <a:bodyPr wrap="square"/>
+                    <a:bodyPr/>
                     <a:lstStyle/>
                     <a:p>
                       <a:pPr algn="ctr"/>
@@ -19946,7 +19129,7 @@
                 </a:tc>
                 <a:tc>
                   <a:txBody>
-                    <a:bodyPr wrap="square"/>
+                    <a:bodyPr/>
                     <a:lstStyle/>
                     <a:p>
                       <a:pPr algn="ctr"/>
@@ -19967,11 +19150,16 @@
                     </a:solidFill>
                   </a:tcPr>
                 </a:tc>
+                <a:extLst>
+                  <a:ext uri="{0D108BD9-81ED-4DB2-BD59-A6C34878D82A}">
+                    <a16:rowId xmlns:a16="http://schemas.microsoft.com/office/drawing/2014/main" val="10000"/>
+                  </a:ext>
+                </a:extLst>
               </a:tr>
               <a:tr h="274320">
                 <a:tc>
                   <a:txBody>
-                    <a:bodyPr wrap="square"/>
+                    <a:bodyPr/>
                     <a:lstStyle/>
                     <a:p>
                       <a:pPr algn="l"/>
@@ -19994,7 +19182,7 @@
                 </a:tc>
                 <a:tc>
                   <a:txBody>
-                    <a:bodyPr wrap="square"/>
+                    <a:bodyPr/>
                     <a:lstStyle/>
                     <a:p>
                       <a:pPr algn="ctr"/>
@@ -20015,11 +19203,16 @@
                     </a:solidFill>
                   </a:tcPr>
                 </a:tc>
+                <a:extLst>
+                  <a:ext uri="{0D108BD9-81ED-4DB2-BD59-A6C34878D82A}">
+                    <a16:rowId xmlns:a16="http://schemas.microsoft.com/office/drawing/2014/main" val="10001"/>
+                  </a:ext>
+                </a:extLst>
               </a:tr>
               <a:tr h="274320">
                 <a:tc>
                   <a:txBody>
-                    <a:bodyPr wrap="square"/>
+                    <a:bodyPr/>
                     <a:lstStyle/>
                     <a:p>
                       <a:pPr algn="l"/>
@@ -20042,19 +19235,34 @@
                 </a:tc>
                 <a:tc>
                   <a:txBody>
-                    <a:bodyPr wrap="square"/>
+                    <a:bodyPr/>
                     <a:lstStyle/>
                     <a:p>
                       <a:pPr algn="ctr"/>
                       <a:r>
-                        <a:rPr sz="1050" b="1">
+                        <a:rPr sz="1050" b="1" dirty="0">
                           <a:solidFill>
                             <a:srgbClr val="000000"/>
                           </a:solidFill>
                           <a:latin typeface="Calibri"/>
                         </a:rPr>
-                        <a:t>0.412</a:t>
+                        <a:t>0.</a:t>
                       </a:r>
+                      <a:r>
+                        <a:rPr lang="en-US" sz="1050" b="1" dirty="0">
+                          <a:solidFill>
+                            <a:srgbClr val="000000"/>
+                          </a:solidFill>
+                          <a:latin typeface="Calibri"/>
+                        </a:rPr>
+                        <a:t>765</a:t>
+                      </a:r>
+                      <a:endParaRPr sz="1050" b="1" dirty="0">
+                        <a:solidFill>
+                          <a:srgbClr val="000000"/>
+                        </a:solidFill>
+                        <a:latin typeface="Calibri"/>
+                      </a:endParaRPr>
                     </a:p>
                   </a:txBody>
                   <a:tcPr marL="64008" marR="64008" marT="27432" marB="27432" anchor="ctr">
@@ -20063,11 +19271,16 @@
                     </a:solidFill>
                   </a:tcPr>
                 </a:tc>
+                <a:extLst>
+                  <a:ext uri="{0D108BD9-81ED-4DB2-BD59-A6C34878D82A}">
+                    <a16:rowId xmlns:a16="http://schemas.microsoft.com/office/drawing/2014/main" val="10002"/>
+                  </a:ext>
+                </a:extLst>
               </a:tr>
               <a:tr h="274320">
                 <a:tc>
                   <a:txBody>
-                    <a:bodyPr wrap="square"/>
+                    <a:bodyPr/>
                     <a:lstStyle/>
                     <a:p>
                       <a:pPr algn="l"/>
@@ -20090,7 +19303,7 @@
                 </a:tc>
                 <a:tc>
                   <a:txBody>
-                    <a:bodyPr wrap="square"/>
+                    <a:bodyPr/>
                     <a:lstStyle/>
                     <a:p>
                       <a:pPr algn="ctr"/>
@@ -20111,11 +19324,16 @@
                     </a:solidFill>
                   </a:tcPr>
                 </a:tc>
+                <a:extLst>
+                  <a:ext uri="{0D108BD9-81ED-4DB2-BD59-A6C34878D82A}">
+                    <a16:rowId xmlns:a16="http://schemas.microsoft.com/office/drawing/2014/main" val="10003"/>
+                  </a:ext>
+                </a:extLst>
               </a:tr>
               <a:tr h="274320">
                 <a:tc>
                   <a:txBody>
-                    <a:bodyPr wrap="square"/>
+                    <a:bodyPr/>
                     <a:lstStyle/>
                     <a:p>
                       <a:pPr algn="l"/>
@@ -20138,7 +19356,7 @@
                 </a:tc>
                 <a:tc>
                   <a:txBody>
-                    <a:bodyPr wrap="square"/>
+                    <a:bodyPr/>
                     <a:lstStyle/>
                     <a:p>
                       <a:pPr algn="ctr"/>
@@ -20159,11 +19377,16 @@
                     </a:solidFill>
                   </a:tcPr>
                 </a:tc>
+                <a:extLst>
+                  <a:ext uri="{0D108BD9-81ED-4DB2-BD59-A6C34878D82A}">
+                    <a16:rowId xmlns:a16="http://schemas.microsoft.com/office/drawing/2014/main" val="10004"/>
+                  </a:ext>
+                </a:extLst>
               </a:tr>
               <a:tr h="274320">
                 <a:tc>
                   <a:txBody>
-                    <a:bodyPr wrap="square"/>
+                    <a:bodyPr/>
                     <a:lstStyle/>
                     <a:p>
                       <a:pPr algn="l"/>
@@ -20186,12 +19409,12 @@
                 </a:tc>
                 <a:tc>
                   <a:txBody>
-                    <a:bodyPr wrap="square"/>
+                    <a:bodyPr/>
                     <a:lstStyle/>
                     <a:p>
                       <a:pPr algn="ctr"/>
                       <a:r>
-                        <a:rPr sz="1050" b="0">
+                        <a:rPr sz="1050" b="0" dirty="0">
                           <a:solidFill>
                             <a:srgbClr val="000000"/>
                           </a:solidFill>
@@ -20207,6 +19430,11 @@
                     </a:solidFill>
                   </a:tcPr>
                 </a:tc>
+                <a:extLst>
+                  <a:ext uri="{0D108BD9-81ED-4DB2-BD59-A6C34878D82A}">
+                    <a16:rowId xmlns:a16="http://schemas.microsoft.com/office/drawing/2014/main" val="10005"/>
+                  </a:ext>
+                </a:extLst>
               </a:tr>
             </a:tbl>
           </a:graphicData>
@@ -20229,7 +19457,7 @@
           <a:noFill/>
         </p:spPr>
         <p:txBody>
-          <a:bodyPr wrap="square" lIns="45720" rIns="45720" tIns="27432" bIns="27432">
+          <a:bodyPr wrap="square" lIns="45720" tIns="27432" rIns="45720" bIns="27432">
             <a:spAutoFit/>
           </a:bodyPr>
           <a:lstStyle/>
@@ -20261,7 +19489,13 @@
           <p:cNvGraphicFramePr>
             <a:graphicFrameLocks noGrp="1"/>
           </p:cNvGraphicFramePr>
-          <p:nvPr/>
+          <p:nvPr>
+            <p:extLst>
+              <p:ext uri="{D42A27DB-BD31-4B8C-83A1-F6EECF244321}">
+                <p14:modId xmlns:p14="http://schemas.microsoft.com/office/powerpoint/2010/main" val="10258456"/>
+              </p:ext>
+            </p:extLst>
+          </p:nvPr>
         </p:nvGraphicFramePr>
         <p:xfrm>
           <a:off x="4892040" y="3063240"/>
@@ -20270,20 +19504,50 @@
         <a:graphic>
           <a:graphicData uri="http://schemas.openxmlformats.org/drawingml/2006/table">
             <a:tbl>
-              <a:tblPr firstRow="0" bandRow="0">
+              <a:tblPr>
                 <a:tableStyleId>{5C22544A-7EE6-4342-B048-85BDC9FD1C3A}</a:tableStyleId>
               </a:tblPr>
               <a:tblGrid>
-                <a:gridCol w="2788920"/>
-                <a:gridCol w="1051560"/>
-                <a:gridCol w="960120"/>
-                <a:gridCol w="1051560"/>
-                <a:gridCol w="1005840"/>
+                <a:gridCol w="2788920">
+                  <a:extLst>
+                    <a:ext uri="{9D8B030D-6E8A-4147-A177-3AD203B41FA5}">
+                      <a16:colId xmlns:a16="http://schemas.microsoft.com/office/drawing/2014/main" val="20000"/>
+                    </a:ext>
+                  </a:extLst>
+                </a:gridCol>
+                <a:gridCol w="1051560">
+                  <a:extLst>
+                    <a:ext uri="{9D8B030D-6E8A-4147-A177-3AD203B41FA5}">
+                      <a16:colId xmlns:a16="http://schemas.microsoft.com/office/drawing/2014/main" val="20001"/>
+                    </a:ext>
+                  </a:extLst>
+                </a:gridCol>
+                <a:gridCol w="960120">
+                  <a:extLst>
+                    <a:ext uri="{9D8B030D-6E8A-4147-A177-3AD203B41FA5}">
+                      <a16:colId xmlns:a16="http://schemas.microsoft.com/office/drawing/2014/main" val="20002"/>
+                    </a:ext>
+                  </a:extLst>
+                </a:gridCol>
+                <a:gridCol w="1051560">
+                  <a:extLst>
+                    <a:ext uri="{9D8B030D-6E8A-4147-A177-3AD203B41FA5}">
+                      <a16:colId xmlns:a16="http://schemas.microsoft.com/office/drawing/2014/main" val="20003"/>
+                    </a:ext>
+                  </a:extLst>
+                </a:gridCol>
+                <a:gridCol w="1005840">
+                  <a:extLst>
+                    <a:ext uri="{9D8B030D-6E8A-4147-A177-3AD203B41FA5}">
+                      <a16:colId xmlns:a16="http://schemas.microsoft.com/office/drawing/2014/main" val="20004"/>
+                    </a:ext>
+                  </a:extLst>
+                </a:gridCol>
               </a:tblGrid>
               <a:tr h="384048">
                 <a:tc>
                   <a:txBody>
-                    <a:bodyPr wrap="square"/>
+                    <a:bodyPr/>
                     <a:lstStyle/>
                     <a:p>
                       <a:pPr algn="ctr"/>
@@ -20306,7 +19570,7 @@
                 </a:tc>
                 <a:tc>
                   <a:txBody>
-                    <a:bodyPr wrap="square"/>
+                    <a:bodyPr/>
                     <a:lstStyle/>
                     <a:p>
                       <a:pPr algn="ctr"/>
@@ -20329,7 +19593,7 @@
                 </a:tc>
                 <a:tc>
                   <a:txBody>
-                    <a:bodyPr wrap="square"/>
+                    <a:bodyPr/>
                     <a:lstStyle/>
                     <a:p>
                       <a:pPr algn="ctr"/>
@@ -20352,7 +19616,7 @@
                 </a:tc>
                 <a:tc>
                   <a:txBody>
-                    <a:bodyPr wrap="square"/>
+                    <a:bodyPr/>
                     <a:lstStyle/>
                     <a:p>
                       <a:pPr algn="ctr"/>
@@ -20375,7 +19639,7 @@
                 </a:tc>
                 <a:tc>
                   <a:txBody>
-                    <a:bodyPr wrap="square"/>
+                    <a:bodyPr/>
                     <a:lstStyle/>
                     <a:p>
                       <a:pPr algn="ctr"/>
@@ -20396,11 +19660,16 @@
                     </a:solidFill>
                   </a:tcPr>
                 </a:tc>
+                <a:extLst>
+                  <a:ext uri="{0D108BD9-81ED-4DB2-BD59-A6C34878D82A}">
+                    <a16:rowId xmlns:a16="http://schemas.microsoft.com/office/drawing/2014/main" val="10000"/>
+                  </a:ext>
+                </a:extLst>
               </a:tr>
               <a:tr h="384048">
                 <a:tc>
                   <a:txBody>
-                    <a:bodyPr wrap="square"/>
+                    <a:bodyPr/>
                     <a:lstStyle/>
                     <a:p>
                       <a:pPr algn="l"/>
@@ -20423,7 +19692,7 @@
                 </a:tc>
                 <a:tc>
                   <a:txBody>
-                    <a:bodyPr wrap="square"/>
+                    <a:bodyPr/>
                     <a:lstStyle/>
                     <a:p>
                       <a:pPr algn="ctr"/>
@@ -20446,7 +19715,7 @@
                 </a:tc>
                 <a:tc>
                   <a:txBody>
-                    <a:bodyPr wrap="square"/>
+                    <a:bodyPr/>
                     <a:lstStyle/>
                     <a:p>
                       <a:pPr algn="ctr"/>
@@ -20469,7 +19738,7 @@
                 </a:tc>
                 <a:tc>
                   <a:txBody>
-                    <a:bodyPr wrap="square"/>
+                    <a:bodyPr/>
                     <a:lstStyle/>
                     <a:p>
                       <a:pPr algn="ctr"/>
@@ -20492,7 +19761,7 @@
                 </a:tc>
                 <a:tc>
                   <a:txBody>
-                    <a:bodyPr wrap="square"/>
+                    <a:bodyPr/>
                     <a:lstStyle/>
                     <a:p>
                       <a:pPr algn="ctr"/>
@@ -20513,22 +19782,45 @@
                     </a:solidFill>
                   </a:tcPr>
                 </a:tc>
+                <a:extLst>
+                  <a:ext uri="{0D108BD9-81ED-4DB2-BD59-A6C34878D82A}">
+                    <a16:rowId xmlns:a16="http://schemas.microsoft.com/office/drawing/2014/main" val="10001"/>
+                  </a:ext>
+                </a:extLst>
               </a:tr>
               <a:tr h="384048">
                 <a:tc>
                   <a:txBody>
-                    <a:bodyPr wrap="square"/>
+                    <a:bodyPr/>
                     <a:lstStyle/>
                     <a:p>
                       <a:pPr algn="l"/>
                       <a:r>
-                        <a:rPr sz="950" b="0">
+                        <a:rPr sz="950" b="0" dirty="0">
                           <a:solidFill>
                             <a:srgbClr val="000000"/>
                           </a:solidFill>
                           <a:latin typeface="Calibri"/>
                         </a:rPr>
-                        <a:t>Full voice path (LiveKit, 100 recordings, judged)</a:t>
+                        <a:t>Full voice path (</a:t>
+                      </a:r>
+                      <a:r>
+                        <a:rPr sz="950" b="0" dirty="0" err="1">
+                          <a:solidFill>
+                            <a:srgbClr val="000000"/>
+                          </a:solidFill>
+                          <a:latin typeface="Calibri"/>
+                        </a:rPr>
+                        <a:t>LiveKit</a:t>
+                      </a:r>
+                      <a:r>
+                        <a:rPr sz="950" b="0" dirty="0">
+                          <a:solidFill>
+                            <a:srgbClr val="000000"/>
+                          </a:solidFill>
+                          <a:latin typeface="Calibri"/>
+                        </a:rPr>
+                        <a:t>, 100 recordings, judged)</a:t>
                       </a:r>
                     </a:p>
                   </a:txBody>
@@ -20540,18 +19832,45 @@
                 </a:tc>
                 <a:tc>
                   <a:txBody>
-                    <a:bodyPr wrap="square"/>
+                    <a:bodyPr/>
                     <a:lstStyle/>
                     <a:p>
                       <a:pPr algn="ctr"/>
                       <a:r>
-                        <a:rPr sz="950" b="1">
+                        <a:rPr lang="en-US" sz="950" b="1" dirty="0">
                           <a:solidFill>
                             <a:srgbClr val="000000"/>
                           </a:solidFill>
                           <a:latin typeface="Calibri"/>
                         </a:rPr>
-                        <a:t>42.0% (41% exact)</a:t>
+                        <a:t>74</a:t>
+                      </a:r>
+                      <a:r>
+                        <a:rPr sz="950" b="1" dirty="0">
+                          <a:solidFill>
+                            <a:srgbClr val="000000"/>
+                          </a:solidFill>
+                          <a:latin typeface="Calibri"/>
+                        </a:rPr>
+                        <a:t>.0% (</a:t>
+                      </a:r>
+                      <a:r>
+                        <a:rPr lang="en-GB" sz="950" b="1" dirty="0">
+                          <a:solidFill>
+                            <a:srgbClr val="000000"/>
+                          </a:solidFill>
+                          <a:latin typeface="Calibri"/>
+                        </a:rPr>
+                        <a:t>68</a:t>
+                      </a:r>
+                      <a:r>
+                        <a:rPr sz="950" b="1" dirty="0">
+                          <a:solidFill>
+                            <a:srgbClr val="000000"/>
+                          </a:solidFill>
+                          <a:latin typeface="Calibri"/>
+                        </a:rPr>
+                        <a:t>% exact)</a:t>
                       </a:r>
                     </a:p>
                   </a:txBody>
@@ -20563,19 +19882,43 @@
                 </a:tc>
                 <a:tc>
                   <a:txBody>
-                    <a:bodyPr wrap="square"/>
+                    <a:bodyPr/>
                     <a:lstStyle/>
                     <a:p>
                       <a:pPr algn="ctr"/>
                       <a:r>
-                        <a:rPr sz="950" b="0">
+                        <a:rPr lang="en-GB" sz="950" b="0" dirty="0">
                           <a:solidFill>
                             <a:srgbClr val="000000"/>
                           </a:solidFill>
                           <a:latin typeface="Calibri"/>
                         </a:rPr>
-                        <a:t>0.844</a:t>
+                        <a:t>0</a:t>
                       </a:r>
+                      <a:r>
+                        <a:rPr sz="950" b="0" dirty="0">
+                          <a:solidFill>
+                            <a:srgbClr val="000000"/>
+                          </a:solidFill>
+                          <a:latin typeface="Calibri"/>
+                        </a:rPr>
+                        <a:t>.</a:t>
+                      </a:r>
+                      <a:r>
+                        <a:rPr lang="en-US" sz="950" b="0" dirty="0">
+                          <a:solidFill>
+                            <a:srgbClr val="000000"/>
+                          </a:solidFill>
+                          <a:latin typeface="Calibri"/>
+                        </a:rPr>
+                        <a:t>959</a:t>
+                      </a:r>
+                      <a:endParaRPr sz="950" b="0" dirty="0">
+                        <a:solidFill>
+                          <a:srgbClr val="000000"/>
+                        </a:solidFill>
+                        <a:latin typeface="Calibri"/>
+                      </a:endParaRPr>
                     </a:p>
                   </a:txBody>
                   <a:tcPr marL="64008" marR="64008" marT="27432" marB="27432" anchor="ctr">
@@ -20586,19 +19929,34 @@
                 </a:tc>
                 <a:tc>
                   <a:txBody>
-                    <a:bodyPr wrap="square"/>
+                    <a:bodyPr/>
                     <a:lstStyle/>
                     <a:p>
                       <a:pPr algn="ctr"/>
                       <a:r>
-                        <a:rPr sz="950" b="0">
+                        <a:rPr sz="950" b="0" dirty="0">
                           <a:solidFill>
                             <a:srgbClr val="000000"/>
                           </a:solidFill>
                           <a:latin typeface="Calibri"/>
                         </a:rPr>
-                        <a:t>0.611</a:t>
+                        <a:t>0.</a:t>
                       </a:r>
+                      <a:r>
+                        <a:rPr lang="en-US" sz="950" b="0" dirty="0">
+                          <a:solidFill>
+                            <a:srgbClr val="000000"/>
+                          </a:solidFill>
+                          <a:latin typeface="Calibri"/>
+                        </a:rPr>
+                        <a:t>780</a:t>
+                      </a:r>
+                      <a:endParaRPr sz="950" b="0" dirty="0">
+                        <a:solidFill>
+                          <a:srgbClr val="000000"/>
+                        </a:solidFill>
+                        <a:latin typeface="Calibri"/>
+                      </a:endParaRPr>
                     </a:p>
                   </a:txBody>
                   <a:tcPr marL="64008" marR="64008" marT="27432" marB="27432" anchor="ctr">
@@ -20609,19 +19967,34 @@
                 </a:tc>
                 <a:tc>
                   <a:txBody>
-                    <a:bodyPr wrap="square"/>
+                    <a:bodyPr/>
                     <a:lstStyle/>
                     <a:p>
                       <a:pPr algn="ctr"/>
                       <a:r>
-                        <a:rPr sz="950" b="0">
+                        <a:rPr sz="950" b="0" dirty="0">
                           <a:solidFill>
                             <a:srgbClr val="000000"/>
                           </a:solidFill>
                           <a:latin typeface="Calibri"/>
                         </a:rPr>
-                        <a:t>0.597</a:t>
+                        <a:t>0.7</a:t>
                       </a:r>
+                      <a:r>
+                        <a:rPr lang="en-US" sz="950" b="0" dirty="0">
+                          <a:solidFill>
+                            <a:srgbClr val="000000"/>
+                          </a:solidFill>
+                          <a:latin typeface="Calibri"/>
+                        </a:rPr>
+                        <a:t>20</a:t>
+                      </a:r>
+                      <a:endParaRPr sz="950" b="0" dirty="0">
+                        <a:solidFill>
+                          <a:srgbClr val="000000"/>
+                        </a:solidFill>
+                        <a:latin typeface="Calibri"/>
+                      </a:endParaRPr>
                     </a:p>
                   </a:txBody>
                   <a:tcPr marL="64008" marR="64008" marT="27432" marB="27432" anchor="ctr">
@@ -20630,11 +20003,16 @@
                     </a:solidFill>
                   </a:tcPr>
                 </a:tc>
+                <a:extLst>
+                  <a:ext uri="{0D108BD9-81ED-4DB2-BD59-A6C34878D82A}">
+                    <a16:rowId xmlns:a16="http://schemas.microsoft.com/office/drawing/2014/main" val="10002"/>
+                  </a:ext>
+                </a:extLst>
               </a:tr>
               <a:tr h="384048">
                 <a:tc>
                   <a:txBody>
-                    <a:bodyPr wrap="square"/>
+                    <a:bodyPr/>
                     <a:lstStyle/>
                     <a:p>
                       <a:pPr algn="l"/>
@@ -20657,7 +20035,7 @@
                 </a:tc>
                 <a:tc>
                   <a:txBody>
-                    <a:bodyPr wrap="square"/>
+                    <a:bodyPr/>
                     <a:lstStyle/>
                     <a:p>
                       <a:pPr algn="ctr"/>
@@ -20680,7 +20058,7 @@
                 </a:tc>
                 <a:tc>
                   <a:txBody>
-                    <a:bodyPr wrap="square"/>
+                    <a:bodyPr/>
                     <a:lstStyle/>
                     <a:p>
                       <a:pPr algn="ctr"/>
@@ -20703,7 +20081,7 @@
                 </a:tc>
                 <a:tc>
                   <a:txBody>
-                    <a:bodyPr wrap="square"/>
+                    <a:bodyPr/>
                     <a:lstStyle/>
                     <a:p>
                       <a:pPr algn="ctr"/>
@@ -20726,12 +20104,12 @@
                 </a:tc>
                 <a:tc>
                   <a:txBody>
-                    <a:bodyPr wrap="square"/>
+                    <a:bodyPr/>
                     <a:lstStyle/>
                     <a:p>
                       <a:pPr algn="ctr"/>
                       <a:r>
-                        <a:rPr sz="950" b="0">
+                        <a:rPr sz="950" b="0" dirty="0">
                           <a:solidFill>
                             <a:srgbClr val="000000"/>
                           </a:solidFill>
@@ -20747,6 +20125,11 @@
                     </a:solidFill>
                   </a:tcPr>
                 </a:tc>
+                <a:extLst>
+                  <a:ext uri="{0D108BD9-81ED-4DB2-BD59-A6C34878D82A}">
+                    <a16:rowId xmlns:a16="http://schemas.microsoft.com/office/drawing/2014/main" val="10003"/>
+                  </a:ext>
+                </a:extLst>
               </a:tr>
             </a:tbl>
           </a:graphicData>
@@ -20761,7 +20144,7 @@
         <p:spPr>
           <a:xfrm>
             <a:off x="4892040" y="4663440"/>
-            <a:ext cx="6903720" cy="1188720"/>
+            <a:ext cx="6903720" cy="914609"/>
           </a:xfrm>
           <a:prstGeom prst="rect">
             <a:avLst/>
@@ -20769,7 +20152,7 @@
           <a:noFill/>
         </p:spPr>
         <p:txBody>
-          <a:bodyPr wrap="square" lIns="45720" rIns="45720" tIns="27432" bIns="27432">
+          <a:bodyPr wrap="square" lIns="45720" tIns="27432" rIns="45720" bIns="27432">
             <a:spAutoFit/>
           </a:bodyPr>
           <a:lstStyle/>
@@ -20784,7 +20167,7 @@
               <a:buNone/>
             </a:pPr>
             <a:r>
-              <a:rPr sz="1050" b="1">
+              <a:rPr sz="1050" b="1" dirty="0">
                 <a:solidFill>
                   <a:srgbClr val="7030A0"/>
                 </a:solidFill>
@@ -20793,7 +20176,7 @@
               <a:t>By domain (text replay): </a:t>
             </a:r>
             <a:r>
-              <a:rPr sz="1050">
+              <a:rPr sz="1050" dirty="0">
                 <a:solidFill>
                   <a:srgbClr val="000000"/>
                 </a:solidFill>
@@ -20813,7 +20196,7 @@
               <a:buNone/>
             </a:pPr>
             <a:r>
-              <a:rPr sz="1050" b="1">
+              <a:rPr sz="1050" b="1" dirty="0">
                 <a:solidFill>
                   <a:srgbClr val="7030A0"/>
                 </a:solidFill>
@@ -20822,7 +20205,7 @@
               <a:t>Latency (voice): </a:t>
             </a:r>
             <a:r>
-              <a:rPr sz="1050">
+              <a:rPr sz="1050" dirty="0">
                 <a:solidFill>
                   <a:srgbClr val="000000"/>
                 </a:solidFill>
@@ -20842,7 +20225,7 @@
               <a:buNone/>
             </a:pPr>
             <a:r>
-              <a:rPr sz="1050" b="1">
+              <a:rPr sz="1050" b="1" dirty="0">
                 <a:solidFill>
                   <a:srgbClr val="7030A0"/>
                 </a:solidFill>
@@ -20851,56 +20234,285 @@
               <a:t>Engineering: </a:t>
             </a:r>
             <a:r>
-              <a:rPr sz="1050">
+              <a:rPr lang="en-US" sz="1050" b="1" dirty="0">
+                <a:latin typeface="Calibri"/>
+              </a:rPr>
+              <a:t>645</a:t>
+            </a:r>
+            <a:r>
+              <a:rPr sz="1050" dirty="0">
                 <a:solidFill>
                   <a:srgbClr val="000000"/>
                 </a:solidFill>
                 <a:latin typeface="Calibri"/>
               </a:rPr>
-              <a:t>499 deterministic tests pass with the trace checker run over every decision log; replays are byte-identical; the adversarial explorer covers 19 race scenarios.</a:t>
+              <a:t> deterministic tests pass with the trace checker run over every decision log; replays are byte-identical; the adversarial explorer covers 19 race scenarios.</a:t>
             </a:r>
+          </a:p>
+        </p:txBody>
+      </p:sp>
+    </p:spTree>
+  </p:cSld>
+  <p:clrMapOvr>
+    <a:masterClrMapping/>
+  </p:clrMapOvr>
+</p:sld>
+</file>
+
+<file path=ppt/slides/slide7.xml><?xml version="1.0" encoding="utf-8"?>
+<p:sld xmlns:a="http://schemas.openxmlformats.org/drawingml/2006/main" xmlns:r="http://schemas.openxmlformats.org/officeDocument/2006/relationships" xmlns:p="http://schemas.openxmlformats.org/presentationml/2006/main">
+  <p:cSld>
+    <p:spTree>
+      <p:nvGrpSpPr>
+        <p:cNvPr id="1" name="Shape 134"/>
+        <p:cNvGrpSpPr/>
+        <p:nvPr/>
+      </p:nvGrpSpPr>
+      <p:grpSpPr>
+        <a:xfrm>
+          <a:off x="0" y="0"/>
+          <a:ext cx="0" cy="0"/>
+          <a:chOff x="0" y="0"/>
+          <a:chExt cx="0" cy="0"/>
+        </a:xfrm>
+      </p:grpSpPr>
+      <p:sp>
+        <p:nvSpPr>
+          <p:cNvPr id="135" name="Google Shape;135;p6"/>
+          <p:cNvSpPr txBox="1">
+            <a:spLocks noGrp="1"/>
+          </p:cNvSpPr>
+          <p:nvPr>
+            <p:ph type="title"/>
+          </p:nvPr>
+        </p:nvSpPr>
+        <p:spPr>
+          <a:xfrm>
+            <a:off x="457200" y="0"/>
+            <a:ext cx="11247120" cy="1325563"/>
+          </a:xfrm>
+          <a:prstGeom prst="rect">
+            <a:avLst/>
+          </a:prstGeom>
+          <a:noFill/>
+          <a:ln>
+            <a:noFill/>
+          </a:ln>
+        </p:spPr>
+        <p:txBody>
+          <a:bodyPr spcFirstLastPara="1" wrap="square" lIns="91425" tIns="45700" rIns="91425" bIns="45700" anchor="ctr" anchorCtr="0">
+            <a:normAutofit/>
+          </a:bodyPr>
+          <a:lstStyle/>
+          <a:p>
+            <a:pPr lvl="0" algn="ctr"/>
+            <a:r>
+              <a:rPr lang="en-US" sz="2800" b="1" dirty="0">
+                <a:solidFill>
+                  <a:srgbClr val="704EA6"/>
+                </a:solidFill>
+              </a:rPr>
+              <a:t>Technology Stack</a:t>
+            </a:r>
+            <a:br>
+              <a:rPr lang="en-US" sz="2800" b="1" dirty="0">
+                <a:solidFill>
+                  <a:srgbClr val="704EA6"/>
+                </a:solidFill>
+              </a:rPr>
+            </a:br>
+            <a:endParaRPr sz="2500" b="1" dirty="0">
+              <a:solidFill>
+                <a:srgbClr val="0F172A"/>
+              </a:solidFill>
+            </a:endParaRPr>
+          </a:p>
+        </p:txBody>
+      </p:sp>
+      <p:pic>
+        <p:nvPicPr>
+          <p:cNvPr id="38" name="Picture 37">
+            <a:extLst>
+              <a:ext uri="{FF2B5EF4-FFF2-40B4-BE49-F238E27FC236}">
+                <a16:creationId xmlns:a16="http://schemas.microsoft.com/office/drawing/2014/main" id="{910767FC-1EAB-DE09-F46A-C3419FCD45CD}"/>
+              </a:ext>
+            </a:extLst>
+          </p:cNvPr>
+          <p:cNvPicPr>
+            <a:picLocks noChangeAspect="1"/>
+          </p:cNvPicPr>
+          <p:nvPr/>
+        </p:nvPicPr>
+        <p:blipFill>
+          <a:blip r:embed="rId3"/>
+          <a:stretch>
+            <a:fillRect/>
+          </a:stretch>
+        </p:blipFill>
+        <p:spPr>
+          <a:xfrm>
+            <a:off x="426720" y="137160"/>
+            <a:ext cx="11338560" cy="6720840"/>
+          </a:xfrm>
+          <a:prstGeom prst="rect">
+            <a:avLst/>
+          </a:prstGeom>
+        </p:spPr>
+      </p:pic>
+    </p:spTree>
+  </p:cSld>
+  <p:clrMapOvr>
+    <a:masterClrMapping/>
+  </p:clrMapOvr>
+</p:sld>
+</file>
+
+<file path=ppt/slides/slide8.xml><?xml version="1.0" encoding="utf-8"?>
+<p:sld xmlns:a="http://schemas.openxmlformats.org/drawingml/2006/main" xmlns:r="http://schemas.openxmlformats.org/officeDocument/2006/relationships" xmlns:p="http://schemas.openxmlformats.org/presentationml/2006/main">
+  <p:cSld>
+    <p:spTree>
+      <p:nvGrpSpPr>
+        <p:cNvPr id="1" name="Shape 146"/>
+        <p:cNvGrpSpPr/>
+        <p:nvPr/>
+      </p:nvGrpSpPr>
+      <p:grpSpPr>
+        <a:xfrm>
+          <a:off x="0" y="0"/>
+          <a:ext cx="0" cy="0"/>
+          <a:chOff x="0" y="0"/>
+          <a:chExt cx="0" cy="0"/>
+        </a:xfrm>
+      </p:grpSpPr>
+      <p:sp>
+        <p:nvSpPr>
+          <p:cNvPr id="147" name="Google Shape;147;p9"/>
+          <p:cNvSpPr txBox="1">
+            <a:spLocks noGrp="1"/>
+          </p:cNvSpPr>
+          <p:nvPr>
+            <p:ph type="title"/>
+          </p:nvPr>
+        </p:nvSpPr>
+        <p:spPr>
+          <a:xfrm>
+            <a:off x="457200" y="228600"/>
+            <a:ext cx="11247120" cy="731520"/>
+          </a:xfrm>
+          <a:prstGeom prst="rect">
+            <a:avLst/>
+          </a:prstGeom>
+          <a:noFill/>
+          <a:ln>
+            <a:noFill/>
+          </a:ln>
+        </p:spPr>
+        <p:txBody>
+          <a:bodyPr spcFirstLastPara="1" wrap="square" lIns="91425" tIns="45700" rIns="91425" bIns="45700" anchor="ctr" anchorCtr="0">
+            <a:normAutofit/>
+          </a:bodyPr>
+          <a:lstStyle/>
+          <a:p>
+            <a:pPr lvl="0"/>
+            <a:r>
+              <a:rPr lang="en-US" sz="3200" b="1" dirty="0">
+                <a:solidFill>
+                  <a:srgbClr val="704EA6"/>
+                </a:solidFill>
+              </a:rPr>
+              <a:t>What’s Next</a:t>
+            </a:r>
+            <a:endParaRPr dirty="0"/>
           </a:p>
         </p:txBody>
       </p:sp>
       <p:sp>
         <p:nvSpPr>
-          <p:cNvPr id="148" name="TextBox 147"/>
-          <p:cNvSpPr txBox="1"/>
-          <p:nvPr/>
+          <p:cNvPr id="148" name="Google Shape;148;p9"/>
+          <p:cNvSpPr txBox="1">
+            <a:spLocks noGrp="1"/>
+          </p:cNvSpPr>
+          <p:nvPr>
+            <p:ph type="body" idx="1"/>
+          </p:nvPr>
         </p:nvSpPr>
         <p:spPr>
           <a:xfrm>
-            <a:off x="411480" y="5852160"/>
-            <a:ext cx="11384280" cy="914400"/>
+            <a:off x="548640" y="1051560"/>
+            <a:ext cx="11064240" cy="5486400"/>
           </a:xfrm>
           <a:prstGeom prst="rect">
             <a:avLst/>
           </a:prstGeom>
           <a:noFill/>
+          <a:ln>
+            <a:noFill/>
+          </a:ln>
         </p:spPr>
         <p:txBody>
-          <a:bodyPr wrap="square" lIns="45720" rIns="45720" tIns="27432" bIns="27432">
-            <a:spAutoFit/>
+          <a:bodyPr spcFirstLastPara="1" wrap="square" lIns="91425" tIns="45700" rIns="91425" bIns="45700" anchor="t" anchorCtr="0">
+            <a:normAutofit lnSpcReduction="10000"/>
           </a:bodyPr>
           <a:lstStyle/>
           <a:p>
-            <a:pPr marL="0" indent="0">
+            <a:pPr marL="201168" lvl="0" indent="-201168">
               <a:spcBef>
                 <a:spcPts val="0"/>
               </a:spcBef>
               <a:spcAft>
                 <a:spcPts val="200"/>
               </a:spcAft>
-              <a:buNone/>
+              <a:buSzPts val="2800"/>
+              <a:buChar char="•"/>
             </a:pPr>
             <a:r>
-              <a:rPr sz="1300" b="1">
+              <a:rPr sz="1900" b="1" dirty="0">
                 <a:solidFill>
                   <a:srgbClr val="7030A0"/>
                 </a:solidFill>
                 <a:latin typeface="Calibri"/>
               </a:rPr>
-              <a:t>Known Limits</a:t>
+              <a:t>Streaming ASR &amp; Entity Recognition</a:t>
+            </a:r>
+          </a:p>
+          <a:p>
+            <a:pPr marL="201168" indent="0">
+              <a:spcBef>
+                <a:spcPts val="0"/>
+              </a:spcBef>
+              <a:spcAft>
+                <a:spcPts val="200"/>
+              </a:spcAft>
+              <a:buNone/>
+            </a:pPr>
+            <a:r>
+              <a:rPr sz="1600" dirty="0">
+                <a:solidFill>
+                  <a:srgbClr val="000000"/>
+                </a:solidFill>
+                <a:latin typeface="Calibri"/>
+              </a:rPr>
+              <a:t>Speech-to-text is already hosted (gpt-4o-mini-transcribe). Next: a streaming ASR (NVIDIA Parakeet) for better proper nouns and lower latency.</a:t>
+            </a:r>
+          </a:p>
+          <a:p>
+            <a:pPr marL="201168" indent="0">
+              <a:spcBef>
+                <a:spcPts val="0"/>
+              </a:spcBef>
+              <a:spcAft>
+                <a:spcPts val="1300"/>
+              </a:spcAft>
+              <a:buNone/>
+            </a:pPr>
+            <a:r>
+              <a:rPr sz="1600" b="1" i="1" dirty="0">
+                <a:solidFill>
+                  <a:srgbClr val="704EA6"/>
+                </a:solidFill>
+                <a:latin typeface="Calibri"/>
+              </a:rPr>
+              <a:t>→ Fewer misheard cities and model numbers</a:t>
             </a:r>
           </a:p>
           <a:p>
@@ -20909,18 +20521,58 @@
                 <a:spcPts val="0"/>
               </a:spcBef>
               <a:spcAft>
-                <a:spcPts val="100"/>
+                <a:spcPts val="200"/>
               </a:spcAft>
               <a:buChar char="•"/>
             </a:pPr>
             <a:r>
-              <a:rPr sz="1100">
+              <a:rPr sz="1900" b="1" dirty="0">
+                <a:solidFill>
+                  <a:srgbClr val="7030A0"/>
+                </a:solidFill>
+                <a:latin typeface="Calibri"/>
+              </a:rPr>
+              <a:t>Proactive Dialogue &amp; Multi-Slot Reasoning</a:t>
+            </a:r>
+          </a:p>
+          <a:p>
+            <a:pPr marL="201168" indent="0">
+              <a:spcBef>
+                <a:spcPts val="0"/>
+              </a:spcBef>
+              <a:spcAft>
+                <a:spcPts val="200"/>
+              </a:spcAft>
+              <a:buNone/>
+            </a:pPr>
+            <a:r>
+              <a:rPr sz="1600" dirty="0">
                 <a:solidFill>
                   <a:srgbClr val="000000"/>
                 </a:solidFill>
                 <a:latin typeface="Calibri"/>
               </a:rPr>
-              <a:t>Voice trails text replay (42.0% vs 77.0%), largely from misheard proper nouns; Housing (35%) is the hardest domain for every published system too.</a:t>
+              <a:t>Move from passive settle-time barriers to clarification dialogues ("I found two options, shall I book the 6 PM one?") and better handling of complex multi-constraint queries (Housing).</a:t>
+            </a:r>
+          </a:p>
+          <a:p>
+            <a:pPr marL="201168" indent="0">
+              <a:spcBef>
+                <a:spcPts val="0"/>
+              </a:spcBef>
+              <a:spcAft>
+                <a:spcPts val="1300"/>
+              </a:spcAft>
+              <a:buNone/>
+            </a:pPr>
+            <a:r>
+              <a:rPr sz="1600" b="1" i="1" dirty="0">
+                <a:solidFill>
+                  <a:srgbClr val="704EA6"/>
+                </a:solidFill>
+                <a:latin typeface="Calibri"/>
+              </a:rPr>
+              <a:t>→ Fewer wrong bookings on hard requests</a:t>
             </a:r>
           </a:p>
           <a:p>
@@ -20929,18 +20581,214 @@
                 <a:spcPts val="0"/>
               </a:spcBef>
               <a:spcAft>
-                <a:spcPts val="0"/>
+                <a:spcPts val="200"/>
               </a:spcAft>
               <a:buChar char="•"/>
             </a:pPr>
             <a:r>
-              <a:rPr sz="1100">
+              <a:rPr sz="1900" b="1" dirty="0">
+                <a:solidFill>
+                  <a:srgbClr val="7030A0"/>
+                </a:solidFill>
+                <a:latin typeface="Calibri"/>
+              </a:rPr>
+              <a:t>Temporal Video Diagnostics</a:t>
+            </a:r>
+          </a:p>
+          <a:p>
+            <a:pPr marL="201168" indent="0">
+              <a:spcBef>
+                <a:spcPts val="0"/>
+              </a:spcBef>
+              <a:spcAft>
+                <a:spcPts val="200"/>
+              </a:spcAft>
+              <a:buNone/>
+            </a:pPr>
+            <a:r>
+              <a:rPr sz="1600" dirty="0">
                 <a:solidFill>
                   <a:srgbClr val="000000"/>
                 </a:solidFill>
                 <a:latin typeface="Calibri"/>
               </a:rPr>
-              <a:t>The hosted Gemini API adds network latency, and the camera is sampled at about 1 fps, so fast LED blinking needs a spoken cue.</a:t>
+              <a:t>Upgrade from 1 fps still frames to multi-frame analysis to detect high-frequency blinking LED patterns and dynamic appliance states.</a:t>
+            </a:r>
+          </a:p>
+          <a:p>
+            <a:pPr marL="201168" indent="0">
+              <a:spcBef>
+                <a:spcPts val="0"/>
+              </a:spcBef>
+              <a:spcAft>
+                <a:spcPts val="1300"/>
+              </a:spcAft>
+              <a:buNone/>
+            </a:pPr>
+            <a:r>
+              <a:rPr sz="1600" b="1" i="1" dirty="0">
+                <a:solidFill>
+                  <a:srgbClr val="704EA6"/>
+                </a:solidFill>
+                <a:latin typeface="Calibri"/>
+              </a:rPr>
+              <a:t>→ Reads blinking-LED codes without a spoken cue</a:t>
+            </a:r>
+          </a:p>
+          <a:p>
+            <a:pPr marL="201168" indent="-201168">
+              <a:spcBef>
+                <a:spcPts val="0"/>
+              </a:spcBef>
+              <a:spcAft>
+                <a:spcPts val="200"/>
+              </a:spcAft>
+              <a:buChar char="•"/>
+            </a:pPr>
+            <a:r>
+              <a:rPr sz="1900" b="1" dirty="0">
+                <a:solidFill>
+                  <a:srgbClr val="7030A0"/>
+                </a:solidFill>
+                <a:latin typeface="Calibri"/>
+              </a:rPr>
+              <a:t>On-Device NPU Porting (Galaxy AI)</a:t>
+            </a:r>
+          </a:p>
+          <a:p>
+            <a:pPr marL="201168" indent="0">
+              <a:spcBef>
+                <a:spcPts val="0"/>
+              </a:spcBef>
+              <a:spcAft>
+                <a:spcPts val="200"/>
+              </a:spcAft>
+              <a:buNone/>
+            </a:pPr>
+            <a:r>
+              <a:rPr sz="1600" dirty="0">
+                <a:solidFill>
+                  <a:srgbClr val="000000"/>
+                </a:solidFill>
+                <a:latin typeface="Calibri"/>
+              </a:rPr>
+              <a:t>Port the lightweight synchronous kernel and local speech stack to Samsung </a:t>
+            </a:r>
+            <a:r>
+              <a:rPr sz="1600" dirty="0" err="1">
+                <a:solidFill>
+                  <a:srgbClr val="000000"/>
+                </a:solidFill>
+                <a:latin typeface="Calibri"/>
+              </a:rPr>
+              <a:t>Exynos</a:t>
+            </a:r>
+            <a:r>
+              <a:rPr sz="1600" dirty="0">
+                <a:solidFill>
+                  <a:srgbClr val="000000"/>
+                </a:solidFill>
+                <a:latin typeface="Calibri"/>
+              </a:rPr>
+              <a:t> / Snapdragon NPUs for offline, ultra-low-latency execution.</a:t>
+            </a:r>
+          </a:p>
+          <a:p>
+            <a:pPr marL="201168" indent="0">
+              <a:spcBef>
+                <a:spcPts val="0"/>
+              </a:spcBef>
+              <a:spcAft>
+                <a:spcPts val="1300"/>
+              </a:spcAft>
+              <a:buNone/>
+            </a:pPr>
+            <a:r>
+              <a:rPr sz="1600" b="1" i="1" dirty="0">
+                <a:solidFill>
+                  <a:srgbClr val="704EA6"/>
+                </a:solidFill>
+                <a:latin typeface="Calibri"/>
+              </a:rPr>
+              <a:t>→ Galaxy devices, offline</a:t>
+            </a:r>
+          </a:p>
+          <a:p>
+            <a:pPr marL="201168" indent="-201168">
+              <a:spcBef>
+                <a:spcPts val="0"/>
+              </a:spcBef>
+              <a:spcAft>
+                <a:spcPts val="200"/>
+              </a:spcAft>
+              <a:buChar char="•"/>
+            </a:pPr>
+            <a:r>
+              <a:rPr sz="1900" b="1" dirty="0">
+                <a:solidFill>
+                  <a:srgbClr val="7030A0"/>
+                </a:solidFill>
+                <a:latin typeface="Calibri"/>
+              </a:rPr>
+              <a:t>Production Samsung Ecosystem Bridge</a:t>
+            </a:r>
+          </a:p>
+          <a:p>
+            <a:pPr marL="201168" indent="0">
+              <a:spcBef>
+                <a:spcPts val="0"/>
+              </a:spcBef>
+              <a:spcAft>
+                <a:spcPts val="200"/>
+              </a:spcAft>
+              <a:buNone/>
+            </a:pPr>
+            <a:r>
+              <a:rPr sz="1600" dirty="0">
+                <a:solidFill>
+                  <a:srgbClr val="000000"/>
+                </a:solidFill>
+                <a:latin typeface="Calibri"/>
+              </a:rPr>
+              <a:t>Plug Samsung Gauss / Bixby in as the reasoning engine via the existing </a:t>
+            </a:r>
+            <a:r>
+              <a:rPr sz="1600" dirty="0" err="1">
+                <a:solidFill>
+                  <a:srgbClr val="000000"/>
+                </a:solidFill>
+                <a:latin typeface="Calibri"/>
+              </a:rPr>
+              <a:t>ModelGateway</a:t>
+            </a:r>
+            <a:r>
+              <a:rPr sz="1600" dirty="0">
+                <a:solidFill>
+                  <a:srgbClr val="000000"/>
+                </a:solidFill>
+                <a:latin typeface="Calibri"/>
+              </a:rPr>
+              <a:t>, plus direct SmartThings and Samsung Care+ APIs for live appliance telemetry, error-code lookup and automated technician dispatch.</a:t>
+            </a:r>
+          </a:p>
+          <a:p>
+            <a:pPr marL="201168" indent="0">
+              <a:spcBef>
+                <a:spcPts val="0"/>
+              </a:spcBef>
+              <a:spcAft>
+                <a:spcPts val="1300"/>
+              </a:spcAft>
+              <a:buNone/>
+            </a:pPr>
+            <a:r>
+              <a:rPr sz="1600" b="1" i="1" dirty="0">
+                <a:solidFill>
+                  <a:srgbClr val="704EA6"/>
+                </a:solidFill>
+                <a:latin typeface="Calibri"/>
+              </a:rPr>
+              <a:t>→ Real Samsung devices, real service tickets</a:t>
             </a:r>
           </a:p>
         </p:txBody>

</xml_diff>